<commit_message>
Align Figure 1 contribution metadata
</commit_message>
<xml_diff>
--- a/paper/figures/fig_overview_camera_ready.pptx
+++ b/paper/figures/fig_overview_camera_ready.pptx
@@ -2,13 +2,13 @@
 <file path=ppt/presentation.xml><?xml version="1.0" encoding="utf-8"?>
 <p:presentation xmlns:p="http://schemas.openxmlformats.org/presentationml/2006/main">
   <p:sldMasterIdLst>
-    <p:sldMasterId xmlns:r="http://schemas.openxmlformats.org/officeDocument/2006/relationships" id="2147483648" r:id="R9b450b311e58460a"/>
+    <p:sldMasterId xmlns:r="http://schemas.openxmlformats.org/officeDocument/2006/relationships" id="2147483648" r:id="R89d30c574afd47fe"/>
   </p:sldMasterIdLst>
   <p:notesMasterIdLst>
-    <p:notesMasterId xmlns:r="http://schemas.openxmlformats.org/officeDocument/2006/relationships" r:id="R0ef639dce5e04405"/>
+    <p:notesMasterId xmlns:r="http://schemas.openxmlformats.org/officeDocument/2006/relationships" r:id="R2f225bebe9d54d31"/>
   </p:notesMasterIdLst>
   <p:sldIdLst>
-    <p:sldId xmlns:r="http://schemas.openxmlformats.org/officeDocument/2006/relationships" id="256" r:id="Rc616c39112d04c80"/>
+    <p:sldId xmlns:r="http://schemas.openxmlformats.org/officeDocument/2006/relationships" id="256" r:id="Rb0fe06361764425f"/>
   </p:sldIdLst>
   <p:sldSz cx="16154400" cy="9001125"/>
   <p:notesSz cx="6858000" cy="9144000"/>
@@ -508,7 +508,7 @@
   </p:cSld>
   <p:clrMap bg1="lt1" tx1="dk1" bg2="lt2" tx2="dk2" accent1="accent1" accent2="accent2" accent3="accent3" accent4="accent4" accent5="accent5" accent6="accent6" hlink="hlink" folHlink="folHlink"/>
   <p:sldLayoutIdLst>
-    <p:sldLayoutId xmlns:r="http://schemas.openxmlformats.org/officeDocument/2006/relationships" id="2147483649" r:id="R570ceb8271eb4634"/>
+    <p:sldLayoutId xmlns:r="http://schemas.openxmlformats.org/officeDocument/2006/relationships" id="2147483649" r:id="Rbaf37e16d36c4e3a"/>
   </p:sldLayoutIdLst>
   <p:txStyles>
     <p:titleStyle>
@@ -4803,7 +4803,7 @@
       </p:sp>
       <p:sp>
         <p:nvSpPr>
-          <p:cNvPr id="80" name="contribution-c3-bg">
+          <p:cNvPr id="80" name="contribution-c2-bg">
             <a:extLst xmlns:a="http://schemas.openxmlformats.org/drawingml/2006/main">
               <a:ext uri="{FF2B5EF4-FFF2-40B4-BE49-F238E27FC236}">
                 <a16:creationId xmlns:a16="http://schemas.microsoft.com/office/drawing/2014/main" id="{34D56896-877C-076C-53FB-73B15133F3C3}"/>
@@ -4838,7 +4838,7 @@
       </p:sp>
       <p:sp>
         <p:nvSpPr>
-          <p:cNvPr id="81" name="contribution-c3-text">
+          <p:cNvPr id="81" name="contribution-c2-text">
             <a:extLst xmlns:a="http://schemas.openxmlformats.org/drawingml/2006/main">
               <a:ext uri="{FF2B5EF4-FFF2-40B4-BE49-F238E27FC236}">
                 <a16:creationId xmlns:a16="http://schemas.microsoft.com/office/drawing/2014/main" id="{7B9D4728-17D9-6179-55AE-177771C3D9AB}"/>
@@ -7515,7 +7515,7 @@
       </p:sp>
       <p:sp>
         <p:nvSpPr>
-          <p:cNvPr id="137" name="contribution-c2-bg">
+          <p:cNvPr id="137" name="contribution-c3-bg">
             <a:extLst xmlns:a="http://schemas.openxmlformats.org/drawingml/2006/main">
               <a:ext uri="{FF2B5EF4-FFF2-40B4-BE49-F238E27FC236}">
                 <a16:creationId xmlns:a16="http://schemas.microsoft.com/office/drawing/2014/main" id="{3AB43F8A-C6D0-FA59-DB70-FE15DA6A314F}"/>
@@ -7557,7 +7557,7 @@
       </p:sp>
       <p:sp>
         <p:nvSpPr>
-          <p:cNvPr id="138" name="contribution-c2-text">
+          <p:cNvPr id="138" name="contribution-c3-text">
             <a:extLst xmlns:a="http://schemas.openxmlformats.org/drawingml/2006/main">
               <a:ext uri="{FF2B5EF4-FFF2-40B4-BE49-F238E27FC236}">
                 <a16:creationId xmlns:a16="http://schemas.microsoft.com/office/drawing/2014/main" id="{D1898C65-7459-718B-0D80-865F71A4ADCA}"/>
@@ -8865,7 +8865,7 @@
       </p:sp>
       <p:cxnSp>
         <p:nvCxnSpPr>
-          <p:cNvPr id="2138" name="직선 화살표 연결선 828"/>
+          <p:cNvPr id="2576" name="직선 화살표 연결선 828"/>
           <p:cNvCxnSpPr>
             <a:stCxn xmlns:a="http://schemas.openxmlformats.org/drawingml/2006/main" id="160" idx="3"/>
             <a:endCxn xmlns:a="http://schemas.openxmlformats.org/drawingml/2006/main" id="161" idx="1"/>
@@ -8893,7 +8893,7 @@
       </p:cxnSp>
       <p:cxnSp>
         <p:nvCxnSpPr>
-          <p:cNvPr id="2139" name="직선 화살표 연결선 829"/>
+          <p:cNvPr id="2577" name="직선 화살표 연결선 829"/>
           <p:cNvCxnSpPr>
             <a:stCxn xmlns:a="http://schemas.openxmlformats.org/drawingml/2006/main" id="30" idx="2"/>
             <a:endCxn xmlns:a="http://schemas.openxmlformats.org/drawingml/2006/main" id="33" idx="0"/>
@@ -8921,7 +8921,7 @@
       </p:cxnSp>
       <p:cxnSp>
         <p:nvCxnSpPr>
-          <p:cNvPr id="2140" name="직선 화살표 연결선 830"/>
+          <p:cNvPr id="2578" name="직선 화살표 연결선 830"/>
           <p:cNvCxnSpPr>
             <a:stCxn xmlns:a="http://schemas.openxmlformats.org/drawingml/2006/main" id="33" idx="2"/>
             <a:endCxn xmlns:a="http://schemas.openxmlformats.org/drawingml/2006/main" id="35" idx="0"/>
@@ -8949,7 +8949,7 @@
       </p:cxnSp>
       <p:cxnSp>
         <p:nvCxnSpPr>
-          <p:cNvPr id="2141" name="직선 화살표 연결선 831"/>
+          <p:cNvPr id="2579" name="직선 화살표 연결선 831"/>
           <p:cNvCxnSpPr>
             <a:stCxn xmlns:a="http://schemas.openxmlformats.org/drawingml/2006/main" id="35" idx="2"/>
             <a:endCxn xmlns:a="http://schemas.openxmlformats.org/drawingml/2006/main" id="38" idx="0"/>
@@ -8977,7 +8977,7 @@
       </p:cxnSp>
       <p:cxnSp>
         <p:nvCxnSpPr>
-          <p:cNvPr id="2142" name="직선 화살표 연결선 832"/>
+          <p:cNvPr id="2580" name="직선 화살표 연결선 832"/>
           <p:cNvCxnSpPr>
             <a:stCxn xmlns:a="http://schemas.openxmlformats.org/drawingml/2006/main" id="38" idx="2"/>
             <a:endCxn xmlns:a="http://schemas.openxmlformats.org/drawingml/2006/main" id="40" idx="0"/>
@@ -9005,7 +9005,7 @@
       </p:cxnSp>
       <p:cxnSp>
         <p:nvCxnSpPr>
-          <p:cNvPr id="2143" name="직선 화살표 연결선 833"/>
+          <p:cNvPr id="2581" name="직선 화살표 연결선 833"/>
           <p:cNvCxnSpPr>
             <a:stCxn xmlns:a="http://schemas.openxmlformats.org/drawingml/2006/main" id="40" idx="2"/>
             <a:endCxn xmlns:a="http://schemas.openxmlformats.org/drawingml/2006/main" id="43" idx="0"/>
@@ -9265,7 +9265,7 @@
       </p:sp>
       <p:cxnSp>
         <p:nvCxnSpPr>
-          <p:cNvPr id="2152" name="직선 화살표 연결선 852"/>
+          <p:cNvPr id="2590" name="직선 화살표 연결선 852"/>
           <p:cNvCxnSpPr>
             <a:stCxn xmlns:a="http://schemas.openxmlformats.org/drawingml/2006/main" id="62" idx="2"/>
             <a:endCxn xmlns:a="http://schemas.openxmlformats.org/drawingml/2006/main" id="72" idx="0"/>
@@ -9293,7 +9293,7 @@
       </p:cxnSp>
       <p:cxnSp>
         <p:nvCxnSpPr>
-          <p:cNvPr id="2153" name="직선 화살표 연결선 853"/>
+          <p:cNvPr id="2591" name="직선 화살표 연결선 853"/>
           <p:cNvCxnSpPr>
             <a:stCxn xmlns:a="http://schemas.openxmlformats.org/drawingml/2006/main" id="72" idx="2"/>
             <a:endCxn xmlns:a="http://schemas.openxmlformats.org/drawingml/2006/main" id="75" idx="0"/>
@@ -9321,7 +9321,7 @@
       </p:cxnSp>
       <p:cxnSp>
         <p:nvCxnSpPr>
-          <p:cNvPr id="2154" name="직선 화살표 연결선 854"/>
+          <p:cNvPr id="2592" name="직선 화살표 연결선 854"/>
           <p:cNvCxnSpPr>
             <a:stCxn xmlns:a="http://schemas.openxmlformats.org/drawingml/2006/main" id="75" idx="2"/>
             <a:endCxn xmlns:a="http://schemas.openxmlformats.org/drawingml/2006/main" id="77" idx="0"/>
@@ -9349,7 +9349,7 @@
       </p:cxnSp>
       <p:cxnSp>
         <p:nvCxnSpPr>
-          <p:cNvPr id="2155" name="직선 화살표 연결선 855"/>
+          <p:cNvPr id="2593" name="직선 화살표 연결선 855"/>
           <p:cNvCxnSpPr>
             <a:stCxn xmlns:a="http://schemas.openxmlformats.org/drawingml/2006/main" id="77" idx="2"/>
             <a:endCxn xmlns:a="http://schemas.openxmlformats.org/drawingml/2006/main" id="82" idx="0"/>
@@ -9609,7 +9609,7 @@
       </p:sp>
       <p:cxnSp>
         <p:nvCxnSpPr>
-          <p:cNvPr id="2164" name="직선 화살표 연결선 867"/>
+          <p:cNvPr id="2602" name="직선 화살표 연결선 867"/>
           <p:cNvCxnSpPr>
             <a:stCxn xmlns:a="http://schemas.openxmlformats.org/drawingml/2006/main" id="197" idx="3"/>
             <a:endCxn xmlns:a="http://schemas.openxmlformats.org/drawingml/2006/main" id="198" idx="1"/>
@@ -9637,7 +9637,7 @@
       </p:cxnSp>
       <p:cxnSp>
         <p:nvCxnSpPr>
-          <p:cNvPr id="2165" name="직선 화살표 연결선 868"/>
+          <p:cNvPr id="2603" name="직선 화살표 연결선 868"/>
           <p:cNvCxnSpPr>
             <a:stCxn xmlns:a="http://schemas.openxmlformats.org/drawingml/2006/main" id="198" idx="0"/>
           </p:cNvCxnSpPr>
@@ -9664,7 +9664,7 @@
       </p:cxnSp>
       <p:cxnSp>
         <p:nvCxnSpPr>
-          <p:cNvPr id="2166" name="직선 화살표 연결선 869"/>
+          <p:cNvPr id="2604" name="직선 화살표 연결선 869"/>
           <p:cNvCxnSpPr>
             <a:endCxn xmlns:a="http://schemas.openxmlformats.org/drawingml/2006/main" id="95" idx="1"/>
           </p:cNvCxnSpPr>
@@ -9691,7 +9691,7 @@
       </p:cxnSp>
       <p:cxnSp>
         <p:nvCxnSpPr>
-          <p:cNvPr id="2167" name="직선 화살표 연결선 870"/>
+          <p:cNvPr id="2605" name="직선 화살표 연결선 870"/>
           <p:cNvCxnSpPr>
             <a:stCxn xmlns:a="http://schemas.openxmlformats.org/drawingml/2006/main" id="95" idx="2"/>
             <a:endCxn xmlns:a="http://schemas.openxmlformats.org/drawingml/2006/main" id="123" idx="0"/>
@@ -9719,7 +9719,7 @@
       </p:cxnSp>
       <p:cxnSp>
         <p:nvCxnSpPr>
-          <p:cNvPr id="2168" name="연결선: 꺾임 872"/>
+          <p:cNvPr id="2606" name="연결선: 꺾임 872"/>
           <p:cNvCxnSpPr>
             <a:stCxn xmlns:a="http://schemas.openxmlformats.org/drawingml/2006/main" id="211" idx="2"/>
             <a:endCxn xmlns:a="http://schemas.openxmlformats.org/drawingml/2006/main" id="128" idx="0"/>
@@ -9749,7 +9749,7 @@
       </p:cxnSp>
       <p:cxnSp>
         <p:nvCxnSpPr>
-          <p:cNvPr id="2169" name="직선 화살표 연결선 871"/>
+          <p:cNvPr id="2607" name="직선 화살표 연결선 871"/>
           <p:cNvCxnSpPr>
             <a:stCxn xmlns:a="http://schemas.openxmlformats.org/drawingml/2006/main" id="123" idx="2"/>
             <a:endCxn xmlns:a="http://schemas.openxmlformats.org/drawingml/2006/main" id="125" idx="0"/>
@@ -9777,7 +9777,7 @@
       </p:cxnSp>
       <p:cxnSp>
         <p:nvCxnSpPr>
-          <p:cNvPr id="2170" name="연결선: 꺾임 874"/>
+          <p:cNvPr id="2608" name="연결선: 꺾임 874"/>
           <p:cNvCxnSpPr>
             <a:stCxn xmlns:a="http://schemas.openxmlformats.org/drawingml/2006/main" id="128" idx="2"/>
             <a:endCxn xmlns:a="http://schemas.openxmlformats.org/drawingml/2006/main" id="134" idx="0"/>
@@ -9808,7 +9808,7 @@
       </p:cxnSp>
       <p:cxnSp>
         <p:nvCxnSpPr>
-          <p:cNvPr id="2171" name="직선 화살표 연결선 875"/>
+          <p:cNvPr id="2609" name="직선 화살표 연결선 875"/>
           <p:cNvCxnSpPr>
             <a:stCxn xmlns:a="http://schemas.openxmlformats.org/drawingml/2006/main" id="130" idx="2"/>
             <a:endCxn xmlns:a="http://schemas.openxmlformats.org/drawingml/2006/main" id="134" idx="0"/>
@@ -9836,7 +9836,7 @@
       </p:cxnSp>
       <p:cxnSp>
         <p:nvCxnSpPr>
-          <p:cNvPr id="2172" name="연결선: 꺾임 876"/>
+          <p:cNvPr id="2610" name="연결선: 꺾임 876"/>
           <p:cNvCxnSpPr>
             <a:stCxn xmlns:a="http://schemas.openxmlformats.org/drawingml/2006/main" id="132" idx="2"/>
             <a:endCxn xmlns:a="http://schemas.openxmlformats.org/drawingml/2006/main" id="134" idx="0"/>
@@ -9867,7 +9867,7 @@
       </p:cxnSp>
       <p:cxnSp>
         <p:nvCxnSpPr>
-          <p:cNvPr id="2173" name="연결선: 꺾임 877"/>
+          <p:cNvPr id="2611" name="연결선: 꺾임 877"/>
           <p:cNvCxnSpPr>
             <a:stCxn xmlns:a="http://schemas.openxmlformats.org/drawingml/2006/main" id="134" idx="2"/>
             <a:endCxn xmlns:a="http://schemas.openxmlformats.org/drawingml/2006/main" id="139" idx="0"/>
@@ -9898,7 +9898,7 @@
       </p:cxnSp>
       <p:cxnSp>
         <p:nvCxnSpPr>
-          <p:cNvPr id="2174" name="직선 화살표 연결선 878"/>
+          <p:cNvPr id="2612" name="직선 화살표 연결선 878"/>
           <p:cNvCxnSpPr>
             <a:stCxn xmlns:a="http://schemas.openxmlformats.org/drawingml/2006/main" id="134" idx="2"/>
             <a:endCxn xmlns:a="http://schemas.openxmlformats.org/drawingml/2006/main" id="142" idx="0"/>
@@ -9926,7 +9926,7 @@
       </p:cxnSp>
       <p:cxnSp>
         <p:nvCxnSpPr>
-          <p:cNvPr id="2175" name="연결선: 꺾임 879"/>
+          <p:cNvPr id="2613" name="연결선: 꺾임 879"/>
           <p:cNvCxnSpPr>
             <a:stCxn xmlns:a="http://schemas.openxmlformats.org/drawingml/2006/main" id="134" idx="2"/>
             <a:endCxn xmlns:a="http://schemas.openxmlformats.org/drawingml/2006/main" id="145" idx="0"/>
@@ -9957,7 +9957,7 @@
       </p:cxnSp>
       <p:cxnSp>
         <p:nvCxnSpPr>
-          <p:cNvPr id="2176" name="직선 화살표 연결선 880"/>
+          <p:cNvPr id="2614" name="직선 화살표 연결선 880"/>
           <p:cNvCxnSpPr>
             <a:stCxn xmlns:a="http://schemas.openxmlformats.org/drawingml/2006/main" id="139" idx="2"/>
             <a:endCxn xmlns:a="http://schemas.openxmlformats.org/drawingml/2006/main" id="148" idx="0"/>
@@ -9985,7 +9985,7 @@
       </p:cxnSp>
       <p:cxnSp>
         <p:nvCxnSpPr>
-          <p:cNvPr id="2177" name="직선 화살표 연결선 881"/>
+          <p:cNvPr id="2615" name="직선 화살표 연결선 881"/>
           <p:cNvCxnSpPr>
             <a:stCxn xmlns:a="http://schemas.openxmlformats.org/drawingml/2006/main" id="142" idx="2"/>
             <a:endCxn xmlns:a="http://schemas.openxmlformats.org/drawingml/2006/main" id="150" idx="0"/>
@@ -10013,7 +10013,7 @@
       </p:cxnSp>
       <p:cxnSp>
         <p:nvCxnSpPr>
-          <p:cNvPr id="2178" name="직선 화살표 연결선 882"/>
+          <p:cNvPr id="2616" name="직선 화살표 연결선 882"/>
           <p:cNvCxnSpPr>
             <a:stCxn xmlns:a="http://schemas.openxmlformats.org/drawingml/2006/main" id="145" idx="2"/>
             <a:endCxn xmlns:a="http://schemas.openxmlformats.org/drawingml/2006/main" id="152" idx="0"/>
@@ -10041,7 +10041,7 @@
       </p:cxnSp>
       <p:cxnSp>
         <p:nvCxnSpPr>
-          <p:cNvPr id="2179" name="연결선: 꺾임 883"/>
+          <p:cNvPr id="2617" name="연결선: 꺾임 883"/>
           <p:cNvCxnSpPr>
             <a:stCxn xmlns:a="http://schemas.openxmlformats.org/drawingml/2006/main" id="148" idx="2"/>
             <a:endCxn xmlns:a="http://schemas.openxmlformats.org/drawingml/2006/main" id="154" idx="0"/>
@@ -10158,7 +10158,7 @@
       </p:sp>
       <p:cxnSp>
         <p:nvCxnSpPr>
-          <p:cNvPr id="2183" name="연결선: 꺾임 161"/>
+          <p:cNvPr id="2621" name="연결선: 꺾임 161"/>
           <p:cNvCxnSpPr>
             <a:stCxn xmlns:a="http://schemas.openxmlformats.org/drawingml/2006/main" id="21" idx="2"/>
             <a:endCxn xmlns:a="http://schemas.openxmlformats.org/drawingml/2006/main" id="62" idx="1"/>
@@ -10201,7 +10201,7 @@
       </p:cxnSp>
       <p:cxnSp>
         <p:nvCxnSpPr>
-          <p:cNvPr id="2184" name="연결선: 꺾임 175"/>
+          <p:cNvPr id="2622" name="연결선: 꺾임 175"/>
           <p:cNvCxnSpPr>
             <a:stCxn xmlns:a="http://schemas.openxmlformats.org/drawingml/2006/main" id="43" idx="3"/>
             <a:endCxn xmlns:a="http://schemas.openxmlformats.org/drawingml/2006/main" id="171" idx="1"/>
@@ -10243,7 +10243,7 @@
       </p:cxnSp>
       <p:cxnSp>
         <p:nvCxnSpPr>
-          <p:cNvPr id="2185" name="직선 화살표 연결선 184"/>
+          <p:cNvPr id="2623" name="직선 화살표 연결선 184"/>
           <p:cNvCxnSpPr>
             <a:stCxn xmlns:a="http://schemas.openxmlformats.org/drawingml/2006/main" id="51" idx="2"/>
             <a:endCxn xmlns:a="http://schemas.openxmlformats.org/drawingml/2006/main" id="53" idx="0"/>
@@ -10271,7 +10271,7 @@
       </p:cxnSp>
       <p:cxnSp>
         <p:nvCxnSpPr>
-          <p:cNvPr id="2186" name="직선 화살표 연결선 188"/>
+          <p:cNvPr id="2624" name="직선 화살표 연결선 188"/>
           <p:cNvCxnSpPr>
             <a:stCxn xmlns:a="http://schemas.openxmlformats.org/drawingml/2006/main" id="53" idx="2"/>
             <a:endCxn xmlns:a="http://schemas.openxmlformats.org/drawingml/2006/main" id="55" idx="0"/>
@@ -10299,7 +10299,7 @@
       </p:cxnSp>
       <p:cxnSp>
         <p:nvCxnSpPr>
-          <p:cNvPr id="2187" name="직선 화살표 연결선 200"/>
+          <p:cNvPr id="2625" name="직선 화살표 연결선 200"/>
           <p:cNvCxnSpPr>
             <a:stCxn xmlns:a="http://schemas.openxmlformats.org/drawingml/2006/main" id="55" idx="2"/>
             <a:endCxn xmlns:a="http://schemas.openxmlformats.org/drawingml/2006/main" id="57" idx="0"/>
@@ -10327,7 +10327,7 @@
       </p:cxnSp>
       <p:cxnSp>
         <p:nvCxnSpPr>
-          <p:cNvPr id="2188" name="연결선: 꺾임 227"/>
+          <p:cNvPr id="2626" name="연결선: 꺾임 227"/>
           <p:cNvCxnSpPr/>
           <p:nvPr/>
         </p:nvCxnSpPr>
@@ -10352,7 +10352,7 @@
       </p:cxnSp>
       <p:cxnSp>
         <p:nvCxnSpPr>
-          <p:cNvPr id="2189" name="직선 화살표 연결선 241"/>
+          <p:cNvPr id="2627" name="직선 화살표 연결선 241"/>
           <p:cNvCxnSpPr>
             <a:stCxn xmlns:a="http://schemas.openxmlformats.org/drawingml/2006/main" id="152" idx="2"/>
             <a:endCxn xmlns:a="http://schemas.openxmlformats.org/drawingml/2006/main" id="248" idx="0"/>
@@ -10380,7 +10380,7 @@
       </p:cxnSp>
       <p:cxnSp>
         <p:nvCxnSpPr>
-          <p:cNvPr id="2190" name="직선 화살표 연결선 253"/>
+          <p:cNvPr id="2628" name="직선 화살표 연결선 253"/>
           <p:cNvCxnSpPr>
             <a:stCxn xmlns:a="http://schemas.openxmlformats.org/drawingml/2006/main" id="150" idx="2"/>
             <a:endCxn xmlns:a="http://schemas.openxmlformats.org/drawingml/2006/main" id="769" idx="0"/>
@@ -10408,14 +10408,14 @@
       </p:cxnSp>
       <p:pic>
         <p:nvPicPr>
-          <p:cNvPr id="2191" name="그림 162"/>
+          <p:cNvPr id="2629" name="그림 162"/>
           <p:cNvPicPr>
             <a:picLocks xmlns:a="http://schemas.openxmlformats.org/drawingml/2006/main" noChangeAspect="1"/>
           </p:cNvPicPr>
           <p:nvPr/>
         </p:nvPicPr>
         <p:blipFill>
-          <a:blip xmlns:r="http://schemas.openxmlformats.org/officeDocument/2006/relationships" xmlns:a="http://schemas.openxmlformats.org/drawingml/2006/main" r:embed="R95f6373081eb4d9d">
+          <a:blip xmlns:r="http://schemas.openxmlformats.org/officeDocument/2006/relationships" xmlns:a="http://schemas.openxmlformats.org/drawingml/2006/main" r:embed="R84d1b27dee104d01">
             <a:biLevel thresh="75000"/>
           </a:blip>
           <a:stretch xmlns:a="http://schemas.openxmlformats.org/drawingml/2006/main">
@@ -10434,14 +10434,14 @@
       </p:pic>
       <p:pic>
         <p:nvPicPr>
-          <p:cNvPr id="2192" name="그림 169"/>
+          <p:cNvPr id="2630" name="그림 169"/>
           <p:cNvPicPr>
             <a:picLocks xmlns:a="http://schemas.openxmlformats.org/drawingml/2006/main" noChangeAspect="1"/>
           </p:cNvPicPr>
           <p:nvPr/>
         </p:nvPicPr>
         <p:blipFill>
-          <a:blip xmlns:r="http://schemas.openxmlformats.org/officeDocument/2006/relationships" xmlns:a="http://schemas.openxmlformats.org/drawingml/2006/main" r:embed="R3a47f761c53f4b39">
+          <a:blip xmlns:r="http://schemas.openxmlformats.org/officeDocument/2006/relationships" xmlns:a="http://schemas.openxmlformats.org/drawingml/2006/main" r:embed="R2344dca673904531">
             <a:duotone>
               <a:schemeClr val="accent4">
                 <a:shade val="45000"/>
@@ -10466,7 +10466,7 @@
       </p:pic>
       <p:cxnSp>
         <p:nvCxnSpPr>
-          <p:cNvPr id="2193" name="직선 화살표 연결선 187"/>
+          <p:cNvPr id="2631" name="직선 화살표 연결선 187"/>
           <p:cNvCxnSpPr>
             <a:stCxn xmlns:a="http://schemas.openxmlformats.org/drawingml/2006/main" id="33" idx="3"/>
             <a:endCxn xmlns:a="http://schemas.openxmlformats.org/drawingml/2006/main" id="51" idx="1"/>
@@ -10494,7 +10494,7 @@
       </p:cxnSp>
       <p:cxnSp>
         <p:nvCxnSpPr>
-          <p:cNvPr id="2194" name="연결선: 꺾임 212"/>
+          <p:cNvPr id="2632" name="연결선: 꺾임 212"/>
           <p:cNvCxnSpPr>
             <a:stCxn xmlns:a="http://schemas.openxmlformats.org/drawingml/2006/main" id="77" idx="3"/>
             <a:endCxn xmlns:a="http://schemas.openxmlformats.org/drawingml/2006/main" id="92" idx="3"/>
@@ -11063,7 +11063,7 @@
       </p:sp>
       <p:cxnSp>
         <p:nvCxnSpPr>
-          <p:cNvPr id="2205" name="직선 화살표 연결선 769"/>
+          <p:cNvPr id="2643" name="직선 화살표 연결선 769"/>
           <p:cNvCxnSpPr>
             <a:stCxn xmlns:a="http://schemas.openxmlformats.org/drawingml/2006/main" id="154" idx="3"/>
             <a:endCxn xmlns:a="http://schemas.openxmlformats.org/drawingml/2006/main" id="236" idx="1"/>

</xml_diff>

<commit_message>
Polish Figure 1 typography and connectors
</commit_message>
<xml_diff>
--- a/paper/figures/fig_overview_camera_ready.pptx
+++ b/paper/figures/fig_overview_camera_ready.pptx
@@ -2,13 +2,13 @@
 <file path=ppt/presentation.xml><?xml version="1.0" encoding="utf-8"?>
 <p:presentation xmlns:p="http://schemas.openxmlformats.org/presentationml/2006/main">
   <p:sldMasterIdLst>
-    <p:sldMasterId xmlns:r="http://schemas.openxmlformats.org/officeDocument/2006/relationships" id="2147483648" r:id="R89d30c574afd47fe"/>
+    <p:sldMasterId xmlns:r="http://schemas.openxmlformats.org/officeDocument/2006/relationships" id="2147483648" r:id="R955f202743f9440f"/>
   </p:sldMasterIdLst>
   <p:notesMasterIdLst>
-    <p:notesMasterId xmlns:r="http://schemas.openxmlformats.org/officeDocument/2006/relationships" r:id="R2f225bebe9d54d31"/>
+    <p:notesMasterId xmlns:r="http://schemas.openxmlformats.org/officeDocument/2006/relationships" r:id="Rdf9340b8106946c2"/>
   </p:notesMasterIdLst>
   <p:sldIdLst>
-    <p:sldId xmlns:r="http://schemas.openxmlformats.org/officeDocument/2006/relationships" id="256" r:id="Rb0fe06361764425f"/>
+    <p:sldId xmlns:r="http://schemas.openxmlformats.org/officeDocument/2006/relationships" id="256" r:id="R34584c023f254118"/>
   </p:sldIdLst>
   <p:sldSz cx="16154400" cy="9001125"/>
   <p:notesSz cx="6858000" cy="9144000"/>
@@ -508,7 +508,7 @@
   </p:cSld>
   <p:clrMap bg1="lt1" tx1="dk1" bg2="lt2" tx2="dk2" accent1="accent1" accent2="accent2" accent3="accent3" accent4="accent4" accent5="accent5" accent6="accent6" hlink="hlink" folHlink="folHlink"/>
   <p:sldLayoutIdLst>
-    <p:sldLayoutId xmlns:r="http://schemas.openxmlformats.org/officeDocument/2006/relationships" id="2147483649" r:id="Rbaf37e16d36c4e3a"/>
+    <p:sldLayoutId xmlns:r="http://schemas.openxmlformats.org/officeDocument/2006/relationships" id="2147483649" r:id="Re860281bae654271"/>
   </p:sldLayoutIdLst>
   <p:txStyles>
     <p:titleStyle>
@@ -2662,7 +2662,7 @@
         <p:spPr>
           <a:xfrm xmlns:a="http://schemas.openxmlformats.org/drawingml/2006/main">
             <a:off x="3429000" y="952500"/>
-            <a:ext cx="2333625" cy="838200"/>
+            <a:ext cx="2333625" cy="800100"/>
           </a:xfrm>
           <a:prstGeom xmlns:a="http://schemas.openxmlformats.org/drawingml/2006/main" prst="roundRect">
             <a:avLst>
@@ -2696,8 +2696,8 @@
         </p:nvSpPr>
         <p:spPr>
           <a:xfrm xmlns:a="http://schemas.openxmlformats.org/drawingml/2006/main">
-            <a:off x="3505200" y="1028700"/>
-            <a:ext cx="2181225" cy="377190"/>
+            <a:off x="3505200" y="1009650"/>
+            <a:ext cx="2181225" cy="323850"/>
           </a:xfrm>
           <a:prstGeom xmlns:a="http://schemas.openxmlformats.org/drawingml/2006/main" prst="rect">
             <a:avLst/>
@@ -2710,7 +2710,7 @@
         </p:spPr>
         <p:txBody>
           <a:bodyPr xmlns:a="http://schemas.openxmlformats.org/drawingml/2006/main" wrap="square" lIns="19050" tIns="9525" rIns="19050" bIns="9525" anchor="ctr">
-            <a:normAutofit/>
+            <a:noAutofit/>
           </a:bodyPr>
           <a:lstStyle xmlns:a="http://schemas.openxmlformats.org/drawingml/2006/main"/>
           <a:p xmlns:a="http://schemas.openxmlformats.org/drawingml/2006/main">
@@ -2737,7 +2737,18 @@
                 <a:ea typeface="Arial"/>
                 <a:cs typeface="Arial"/>
               </a:rPr>
-              <a:t>Parser candidates P_i</a:t>
+              <a:t>Parser candidates </a:t>
+            </a:r>
+            <a:r>
+              <a:rPr sz="1350" b="1" i="1">
+                <a:solidFill>
+                  <a:srgbClr val="FFFFFF"/>
+                </a:solidFill>
+                <a:latin typeface="Arial"/>
+                <a:ea typeface="Arial"/>
+                <a:cs typeface="Arial"/>
+              </a:rPr>
+              <a:t>Pᵢ</a:t>
             </a:r>
           </a:p>
         </p:txBody>
@@ -2758,8 +2769,8 @@
         </p:nvSpPr>
         <p:spPr>
           <a:xfrm xmlns:a="http://schemas.openxmlformats.org/drawingml/2006/main">
-            <a:off x="3505200" y="1346454"/>
-            <a:ext cx="2181225" cy="360426"/>
+            <a:off x="3505200" y="1352550"/>
+            <a:ext cx="2181225" cy="323850"/>
           </a:xfrm>
           <a:prstGeom xmlns:a="http://schemas.openxmlformats.org/drawingml/2006/main" prst="rect">
             <a:avLst/>
@@ -2772,7 +2783,7 @@
         </p:spPr>
         <p:txBody>
           <a:bodyPr xmlns:a="http://schemas.openxmlformats.org/drawingml/2006/main" wrap="square" lIns="19050" tIns="9525" rIns="19050" bIns="9525" anchor="ctr">
-            <a:normAutofit/>
+            <a:noAutofit/>
           </a:bodyPr>
           <a:lstStyle xmlns:a="http://schemas.openxmlformats.org/drawingml/2006/main"/>
           <a:p xmlns:a="http://schemas.openxmlformats.org/drawingml/2006/main">
@@ -2791,6 +2802,17 @@
               </a:defRPr>
             </a:pPr>
             <a:r>
+              <a:rPr sz="1200" b="0" i="1">
+                <a:solidFill>
+                  <a:srgbClr val="E4EDF3"/>
+                </a:solidFill>
+                <a:latin typeface="Arial"/>
+                <a:ea typeface="Arial"/>
+                <a:cs typeface="Arial"/>
+              </a:rPr>
+              <a:t>P₁</a:t>
+            </a:r>
+            <a:r>
               <a:rPr sz="1200" b="0" i="0">
                 <a:solidFill>
                   <a:srgbClr val="E4EDF3"/>
@@ -2799,7 +2821,40 @@
                 <a:ea typeface="Arial"/>
                 <a:cs typeface="Arial"/>
               </a:rPr>
-              <a:t>P_1   P_2   ...   P_m</a:t>
+              <a:t>   </a:t>
+            </a:r>
+            <a:r>
+              <a:rPr sz="1200" b="0" i="1">
+                <a:solidFill>
+                  <a:srgbClr val="E4EDF3"/>
+                </a:solidFill>
+                <a:latin typeface="Arial"/>
+                <a:ea typeface="Arial"/>
+                <a:cs typeface="Arial"/>
+              </a:rPr>
+              <a:t>P₂</a:t>
+            </a:r>
+            <a:r>
+              <a:rPr sz="1200" b="0" i="0">
+                <a:solidFill>
+                  <a:srgbClr val="E4EDF3"/>
+                </a:solidFill>
+                <a:latin typeface="Arial"/>
+                <a:ea typeface="Arial"/>
+                <a:cs typeface="Arial"/>
+              </a:rPr>
+              <a:t>   …   </a:t>
+            </a:r>
+            <a:r>
+              <a:rPr sz="1200" b="0" i="1">
+                <a:solidFill>
+                  <a:srgbClr val="E4EDF3"/>
+                </a:solidFill>
+                <a:latin typeface="Arial"/>
+                <a:ea typeface="Arial"/>
+                <a:cs typeface="Arial"/>
+              </a:rPr>
+              <a:t>Pₘ</a:t>
             </a:r>
           </a:p>
         </p:txBody>
@@ -2820,8 +2875,8 @@
         </p:nvSpPr>
         <p:spPr>
           <a:xfrm xmlns:a="http://schemas.openxmlformats.org/drawingml/2006/main">
-            <a:off x="3429000" y="2114550"/>
-            <a:ext cx="2333625" cy="704850"/>
+            <a:off x="3429000" y="2095500"/>
+            <a:ext cx="2333625" cy="742950"/>
           </a:xfrm>
           <a:prstGeom xmlns:a="http://schemas.openxmlformats.org/drawingml/2006/main" prst="roundRect">
             <a:avLst>
@@ -2855,8 +2910,8 @@
         </p:nvSpPr>
         <p:spPr>
           <a:xfrm xmlns:a="http://schemas.openxmlformats.org/drawingml/2006/main">
-            <a:off x="3505200" y="2171700"/>
-            <a:ext cx="2181225" cy="590550"/>
+            <a:off x="3505200" y="2305050"/>
+            <a:ext cx="2181225" cy="323850"/>
           </a:xfrm>
           <a:prstGeom xmlns:a="http://schemas.openxmlformats.org/drawingml/2006/main" prst="rect">
             <a:avLst/>
@@ -2869,7 +2924,7 @@
         </p:spPr>
         <p:txBody>
           <a:bodyPr xmlns:a="http://schemas.openxmlformats.org/drawingml/2006/main" wrap="square" lIns="19050" tIns="9525" rIns="19050" bIns="9525" anchor="ctr">
-            <a:normAutofit/>
+            <a:noAutofit/>
           </a:bodyPr>
           <a:lstStyle xmlns:a="http://schemas.openxmlformats.org/drawingml/2006/main"/>
           <a:p xmlns:a="http://schemas.openxmlformats.org/drawingml/2006/main">
@@ -2888,7 +2943,7 @@
               </a:defRPr>
             </a:pPr>
             <a:r>
-              <a:rPr sz="1425" b="1" i="0">
+              <a:rPr sz="1350" b="1" i="0">
                 <a:solidFill>
                   <a:srgbClr val="FFFFFF"/>
                 </a:solidFill>
@@ -2952,8 +3007,8 @@
         </p:nvSpPr>
         <p:spPr>
           <a:xfrm xmlns:a="http://schemas.openxmlformats.org/drawingml/2006/main">
-            <a:off x="3505200" y="3238500"/>
-            <a:ext cx="2181225" cy="360045"/>
+            <a:off x="3505200" y="3219450"/>
+            <a:ext cx="2181225" cy="323850"/>
           </a:xfrm>
           <a:prstGeom xmlns:a="http://schemas.openxmlformats.org/drawingml/2006/main" prst="rect">
             <a:avLst/>
@@ -2966,7 +3021,7 @@
         </p:spPr>
         <p:txBody>
           <a:bodyPr xmlns:a="http://schemas.openxmlformats.org/drawingml/2006/main" wrap="square" lIns="19050" tIns="9525" rIns="19050" bIns="9525" anchor="ctr">
-            <a:normAutofit/>
+            <a:noAutofit/>
           </a:bodyPr>
           <a:lstStyle xmlns:a="http://schemas.openxmlformats.org/drawingml/2006/main"/>
           <a:p xmlns:a="http://schemas.openxmlformats.org/drawingml/2006/main">
@@ -2993,7 +3048,18 @@
                 <a:ea typeface="Arial"/>
                 <a:cs typeface="Arial"/>
               </a:rPr>
-              <a:t>Chunker candidates C_j</a:t>
+              <a:t>Chunker candidates </a:t>
+            </a:r>
+            <a:r>
+              <a:rPr sz="1350" b="1" i="1">
+                <a:solidFill>
+                  <a:srgbClr val="FFFFFF"/>
+                </a:solidFill>
+                <a:latin typeface="Arial"/>
+                <a:ea typeface="Arial"/>
+                <a:cs typeface="Arial"/>
+              </a:rPr>
+              <a:t>Cⱼ</a:t>
             </a:r>
           </a:p>
         </p:txBody>
@@ -3014,8 +3080,8 @@
         </p:nvSpPr>
         <p:spPr>
           <a:xfrm xmlns:a="http://schemas.openxmlformats.org/drawingml/2006/main">
-            <a:off x="3505200" y="3538347"/>
-            <a:ext cx="2181225" cy="344043"/>
+            <a:off x="3505200" y="3562350"/>
+            <a:ext cx="2181225" cy="323850"/>
           </a:xfrm>
           <a:prstGeom xmlns:a="http://schemas.openxmlformats.org/drawingml/2006/main" prst="rect">
             <a:avLst/>
@@ -3028,7 +3094,7 @@
         </p:spPr>
         <p:txBody>
           <a:bodyPr xmlns:a="http://schemas.openxmlformats.org/drawingml/2006/main" wrap="square" lIns="19050" tIns="9525" rIns="19050" bIns="9525" anchor="ctr">
-            <a:normAutofit/>
+            <a:noAutofit/>
           </a:bodyPr>
           <a:lstStyle xmlns:a="http://schemas.openxmlformats.org/drawingml/2006/main"/>
           <a:p xmlns:a="http://schemas.openxmlformats.org/drawingml/2006/main">
@@ -3047,6 +3113,17 @@
               </a:defRPr>
             </a:pPr>
             <a:r>
+              <a:rPr sz="1200" b="0" i="1">
+                <a:solidFill>
+                  <a:srgbClr val="E4EDF3"/>
+                </a:solidFill>
+                <a:latin typeface="Arial"/>
+                <a:ea typeface="Arial"/>
+                <a:cs typeface="Arial"/>
+              </a:rPr>
+              <a:t>C₁</a:t>
+            </a:r>
+            <a:r>
               <a:rPr sz="1200" b="0" i="0">
                 <a:solidFill>
                   <a:srgbClr val="E4EDF3"/>
@@ -3055,7 +3132,40 @@
                 <a:ea typeface="Arial"/>
                 <a:cs typeface="Arial"/>
               </a:rPr>
-              <a:t>C_1   C_2   ...   C_c</a:t>
+              <a:t>   </a:t>
+            </a:r>
+            <a:r>
+              <a:rPr sz="1200" b="0" i="1">
+                <a:solidFill>
+                  <a:srgbClr val="E4EDF3"/>
+                </a:solidFill>
+                <a:latin typeface="Arial"/>
+                <a:ea typeface="Arial"/>
+                <a:cs typeface="Arial"/>
+              </a:rPr>
+              <a:t>C₂</a:t>
+            </a:r>
+            <a:r>
+              <a:rPr sz="1200" b="0" i="0">
+                <a:solidFill>
+                  <a:srgbClr val="E4EDF3"/>
+                </a:solidFill>
+                <a:latin typeface="Arial"/>
+                <a:ea typeface="Arial"/>
+                <a:cs typeface="Arial"/>
+              </a:rPr>
+              <a:t>   …   </a:t>
+            </a:r>
+            <a:r>
+              <a:rPr sz="1200" b="0" i="1">
+                <a:solidFill>
+                  <a:srgbClr val="E4EDF3"/>
+                </a:solidFill>
+                <a:latin typeface="Arial"/>
+                <a:ea typeface="Arial"/>
+                <a:cs typeface="Arial"/>
+              </a:rPr>
+              <a:t>C꜀</a:t>
             </a:r>
           </a:p>
         </p:txBody>
@@ -3076,8 +3186,8 @@
         </p:nvSpPr>
         <p:spPr>
           <a:xfrm xmlns:a="http://schemas.openxmlformats.org/drawingml/2006/main">
-            <a:off x="3714750" y="4267200"/>
-            <a:ext cx="1762125" cy="400050"/>
+            <a:off x="3429000" y="4267200"/>
+            <a:ext cx="2333625" cy="400050"/>
           </a:xfrm>
           <a:prstGeom xmlns:a="http://schemas.openxmlformats.org/drawingml/2006/main" prst="roundRect">
             <a:avLst>
@@ -3111,8 +3221,8 @@
         </p:nvSpPr>
         <p:spPr>
           <a:xfrm xmlns:a="http://schemas.openxmlformats.org/drawingml/2006/main">
-            <a:off x="3743325" y="4286250"/>
-            <a:ext cx="1704975" cy="361950"/>
+            <a:off x="3457575" y="4286250"/>
+            <a:ext cx="2276475" cy="361950"/>
           </a:xfrm>
           <a:prstGeom xmlns:a="http://schemas.openxmlformats.org/drawingml/2006/main" prst="rect">
             <a:avLst/>
@@ -3125,7 +3235,7 @@
         </p:spPr>
         <p:txBody>
           <a:bodyPr xmlns:a="http://schemas.openxmlformats.org/drawingml/2006/main" wrap="square" lIns="19050" tIns="9525" rIns="19050" bIns="9525" anchor="ctr">
-            <a:normAutofit/>
+            <a:normAutofit fontScale="100000"/>
           </a:bodyPr>
           <a:lstStyle xmlns:a="http://schemas.openxmlformats.org/drawingml/2006/main"/>
           <a:p xmlns:a="http://schemas.openxmlformats.org/drawingml/2006/main">
@@ -3152,7 +3262,51 @@
                 <a:ea typeface="Arial"/>
                 <a:cs typeface="Arial"/>
               </a:rPr>
-              <a:t>all P_i x C_j pairs</a:t>
+              <a:t>all </a:t>
+            </a:r>
+            <a:r>
+              <a:rPr sz="1200" b="1" i="1">
+                <a:solidFill>
+                  <a:srgbClr val="1D2B36"/>
+                </a:solidFill>
+                <a:latin typeface="Arial"/>
+                <a:ea typeface="Arial"/>
+                <a:cs typeface="Arial"/>
+              </a:rPr>
+              <a:t>Pᵢ</a:t>
+            </a:r>
+            <a:r>
+              <a:rPr sz="1200" b="1" i="0">
+                <a:solidFill>
+                  <a:srgbClr val="1D2B36"/>
+                </a:solidFill>
+                <a:latin typeface="Arial"/>
+                <a:ea typeface="Arial"/>
+                <a:cs typeface="Arial"/>
+              </a:rPr>
+              <a:t> × </a:t>
+            </a:r>
+            <a:r>
+              <a:rPr sz="1200" b="1" i="1">
+                <a:solidFill>
+                  <a:srgbClr val="1D2B36"/>
+                </a:solidFill>
+                <a:latin typeface="Arial"/>
+                <a:ea typeface="Arial"/>
+                <a:cs typeface="Arial"/>
+              </a:rPr>
+              <a:t>Cⱼ</a:t>
+            </a:r>
+            <a:r>
+              <a:rPr sz="1200" b="1" i="0">
+                <a:solidFill>
+                  <a:srgbClr val="1D2B36"/>
+                </a:solidFill>
+                <a:latin typeface="Arial"/>
+                <a:ea typeface="Arial"/>
+                <a:cs typeface="Arial"/>
+              </a:rPr>
+              <a:t> pairs</a:t>
             </a:r>
           </a:p>
         </p:txBody>
@@ -3174,7 +3328,7 @@
         <p:spPr>
           <a:xfrm xmlns:a="http://schemas.openxmlformats.org/drawingml/2006/main">
             <a:off x="3429000" y="5095875"/>
-            <a:ext cx="2333625" cy="914400"/>
+            <a:ext cx="2333625" cy="876300"/>
           </a:xfrm>
           <a:prstGeom xmlns:a="http://schemas.openxmlformats.org/drawingml/2006/main" prst="roundRect">
             <a:avLst>
@@ -3215,8 +3369,8 @@
         </p:nvSpPr>
         <p:spPr>
           <a:xfrm xmlns:a="http://schemas.openxmlformats.org/drawingml/2006/main">
-            <a:off x="3505200" y="5172075"/>
-            <a:ext cx="2181225" cy="411480"/>
+            <a:off x="3505200" y="5162550"/>
+            <a:ext cx="2181225" cy="323850"/>
           </a:xfrm>
           <a:prstGeom xmlns:a="http://schemas.openxmlformats.org/drawingml/2006/main" prst="rect">
             <a:avLst/>
@@ -3229,7 +3383,7 @@
         </p:spPr>
         <p:txBody>
           <a:bodyPr xmlns:a="http://schemas.openxmlformats.org/drawingml/2006/main" wrap="square" lIns="19050" tIns="9525" rIns="19050" bIns="9525" anchor="ctr">
-            <a:normAutofit/>
+            <a:noAutofit/>
           </a:bodyPr>
           <a:lstStyle xmlns:a="http://schemas.openxmlformats.org/drawingml/2006/main"/>
           <a:p xmlns:a="http://schemas.openxmlformats.org/drawingml/2006/main">
@@ -3248,7 +3402,7 @@
               </a:defRPr>
             </a:pPr>
             <a:r>
-              <a:rPr sz="1425" b="1" i="0">
+              <a:rPr sz="1350" b="1" i="0">
                 <a:solidFill>
                   <a:srgbClr val="FFFFFF"/>
                 </a:solidFill>
@@ -3277,8 +3431,8 @@
         </p:nvSpPr>
         <p:spPr>
           <a:xfrm xmlns:a="http://schemas.openxmlformats.org/drawingml/2006/main">
-            <a:off x="3505200" y="5525643"/>
-            <a:ext cx="2181225" cy="393192"/>
+            <a:off x="3505200" y="5524500"/>
+            <a:ext cx="2181225" cy="323850"/>
           </a:xfrm>
           <a:prstGeom xmlns:a="http://schemas.openxmlformats.org/drawingml/2006/main" prst="rect">
             <a:avLst/>
@@ -3291,7 +3445,7 @@
         </p:spPr>
         <p:txBody>
           <a:bodyPr xmlns:a="http://schemas.openxmlformats.org/drawingml/2006/main" wrap="square" lIns="19050" tIns="9525" rIns="19050" bIns="9525" anchor="ctr">
-            <a:normAutofit/>
+            <a:noAutofit/>
           </a:bodyPr>
           <a:lstStyle xmlns:a="http://schemas.openxmlformats.org/drawingml/2006/main"/>
           <a:p xmlns:a="http://schemas.openxmlformats.org/drawingml/2006/main">
@@ -3310,6 +3464,17 @@
               </a:defRPr>
             </a:pPr>
             <a:r>
+              <a:rPr sz="1200" b="0" i="1">
+                <a:solidFill>
+                  <a:srgbClr val="E4EDF3"/>
+                </a:solidFill>
+                <a:latin typeface="Arial"/>
+                <a:ea typeface="Arial"/>
+                <a:cs typeface="Arial"/>
+              </a:rPr>
+              <a:t>Cⱼ</a:t>
+            </a:r>
+            <a:r>
               <a:rPr sz="1200" b="0" i="0">
                 <a:solidFill>
                   <a:srgbClr val="E4EDF3"/>
@@ -3318,7 +3483,18 @@
                 <a:ea typeface="Arial"/>
                 <a:cs typeface="Arial"/>
               </a:rPr>
-              <a:t>C_j</a:t>
+              <a:t>(</a:t>
+            </a:r>
+            <a:r>
+              <a:rPr sz="1200" b="0" i="1">
+                <a:solidFill>
+                  <a:srgbClr val="E4EDF3"/>
+                </a:solidFill>
+                <a:latin typeface="Arial"/>
+                <a:ea typeface="Arial"/>
+                <a:cs typeface="Arial"/>
+              </a:rPr>
+              <a:t>Pᵢ</a:t>
             </a:r>
             <a:r>
               <a:rPr sz="1200" b="0" i="0">
@@ -3329,7 +3505,18 @@
                 <a:ea typeface="Arial"/>
                 <a:cs typeface="Arial"/>
               </a:rPr>
-              <a:t>(</a:t>
+              <a:t>),  </a:t>
+            </a:r>
+            <a:r>
+              <a:rPr sz="1200" b="0" i="1">
+                <a:solidFill>
+                  <a:srgbClr val="E4EDF3"/>
+                </a:solidFill>
+                <a:latin typeface="Arial"/>
+                <a:ea typeface="Arial"/>
+                <a:cs typeface="Arial"/>
+              </a:rPr>
+              <a:t>m</a:t>
             </a:r>
             <a:r>
               <a:rPr sz="1200" b="0" i="0">
@@ -3340,10 +3527,10 @@
                 <a:ea typeface="Arial"/>
                 <a:cs typeface="Arial"/>
               </a:rPr>
-              <a:t>P_i</a:t>
-            </a:r>
-            <a:r>
-              <a:rPr sz="1200" b="0" i="0">
+              <a:t> × </a:t>
+            </a:r>
+            <a:r>
+              <a:rPr sz="1200" b="0" i="1">
                 <a:solidFill>
                   <a:srgbClr val="E4EDF3"/>
                 </a:solidFill>
@@ -3351,7 +3538,7 @@
                 <a:ea typeface="Arial"/>
                 <a:cs typeface="Arial"/>
               </a:rPr>
-              <a:t>),  m x c</a:t>
+              <a:t>c</a:t>
             </a:r>
           </a:p>
         </p:txBody>
@@ -3373,7 +3560,7 @@
         <p:spPr>
           <a:xfrm xmlns:a="http://schemas.openxmlformats.org/drawingml/2006/main">
             <a:off x="3429000" y="6667500"/>
-            <a:ext cx="2333625" cy="990600"/>
+            <a:ext cx="2333625" cy="933450"/>
           </a:xfrm>
           <a:prstGeom xmlns:a="http://schemas.openxmlformats.org/drawingml/2006/main" prst="roundRect">
             <a:avLst>
@@ -3414,7 +3601,7 @@
         </p:nvSpPr>
         <p:spPr>
           <a:xfrm xmlns:a="http://schemas.openxmlformats.org/drawingml/2006/main">
-            <a:off x="4000500" y="7000875"/>
+            <a:off x="4000500" y="6972300"/>
             <a:ext cx="1714500" cy="323850"/>
           </a:xfrm>
           <a:prstGeom xmlns:a="http://schemas.openxmlformats.org/drawingml/2006/main" prst="rect">
@@ -3428,7 +3615,7 @@
         </p:spPr>
         <p:txBody>
           <a:bodyPr xmlns:a="http://schemas.openxmlformats.org/drawingml/2006/main" wrap="square" lIns="19050" tIns="9525" rIns="19050" bIns="9525" anchor="ctr">
-            <a:normAutofit/>
+            <a:noAutofit/>
           </a:bodyPr>
           <a:lstStyle xmlns:a="http://schemas.openxmlformats.org/drawingml/2006/main"/>
           <a:p xmlns:a="http://schemas.openxmlformats.org/drawingml/2006/main">
@@ -3476,8 +3663,8 @@
         </p:nvSpPr>
         <p:spPr>
           <a:xfrm xmlns:a="http://schemas.openxmlformats.org/drawingml/2006/main">
-            <a:off x="5993607" y="2176008"/>
-            <a:ext cx="962025" cy="590551"/>
+            <a:off x="5993606" y="2162175"/>
+            <a:ext cx="962025" cy="609600"/>
           </a:xfrm>
           <a:prstGeom xmlns:a="http://schemas.openxmlformats.org/drawingml/2006/main" prst="roundRect">
             <a:avLst>
@@ -3518,8 +3705,8 @@
         </p:nvSpPr>
         <p:spPr>
           <a:xfrm xmlns:a="http://schemas.openxmlformats.org/drawingml/2006/main">
-            <a:off x="6069807" y="2109334"/>
-            <a:ext cx="809625" cy="781050"/>
+            <a:off x="6069806" y="2219325"/>
+            <a:ext cx="809625" cy="495300"/>
           </a:xfrm>
           <a:prstGeom xmlns:a="http://schemas.openxmlformats.org/drawingml/2006/main" prst="rect">
             <a:avLst/>
@@ -3532,7 +3719,7 @@
         </p:spPr>
         <p:txBody>
           <a:bodyPr xmlns:a="http://schemas.openxmlformats.org/drawingml/2006/main" wrap="square" lIns="19050" tIns="9525" rIns="19050" bIns="9525" anchor="ctr">
-            <a:normAutofit/>
+            <a:noAutofit/>
           </a:bodyPr>
           <a:lstStyle xmlns:a="http://schemas.openxmlformats.org/drawingml/2006/main"/>
           <a:p xmlns:a="http://schemas.openxmlformats.org/drawingml/2006/main">
@@ -3607,8 +3794,8 @@
         </p:nvSpPr>
         <p:spPr>
           <a:xfrm xmlns:a="http://schemas.openxmlformats.org/drawingml/2006/main">
-            <a:off x="5993607" y="3152775"/>
-            <a:ext cx="962025" cy="639309"/>
+            <a:off x="5993606" y="3152775"/>
+            <a:ext cx="962025" cy="609600"/>
           </a:xfrm>
           <a:prstGeom xmlns:a="http://schemas.openxmlformats.org/drawingml/2006/main" prst="roundRect">
             <a:avLst>
@@ -3649,8 +3836,8 @@
         </p:nvSpPr>
         <p:spPr>
           <a:xfrm xmlns:a="http://schemas.openxmlformats.org/drawingml/2006/main">
-            <a:off x="6069807" y="3209925"/>
-            <a:ext cx="809625" cy="545752"/>
+            <a:off x="6069806" y="3209925"/>
+            <a:ext cx="809625" cy="495300"/>
           </a:xfrm>
           <a:prstGeom xmlns:a="http://schemas.openxmlformats.org/drawingml/2006/main" prst="rect">
             <a:avLst/>
@@ -3663,7 +3850,7 @@
         </p:spPr>
         <p:txBody>
           <a:bodyPr xmlns:a="http://schemas.openxmlformats.org/drawingml/2006/main" wrap="square" lIns="19050" tIns="9525" rIns="19050" bIns="9525" anchor="ctr">
-            <a:normAutofit/>
+            <a:noAutofit/>
           </a:bodyPr>
           <a:lstStyle xmlns:a="http://schemas.openxmlformats.org/drawingml/2006/main"/>
           <a:p xmlns:a="http://schemas.openxmlformats.org/drawingml/2006/main">
@@ -3738,8 +3925,8 @@
         </p:nvSpPr>
         <p:spPr>
           <a:xfrm xmlns:a="http://schemas.openxmlformats.org/drawingml/2006/main">
-            <a:off x="5879307" y="4105275"/>
-            <a:ext cx="1200150" cy="666750"/>
+            <a:off x="5879306" y="4105275"/>
+            <a:ext cx="1200150" cy="647700"/>
           </a:xfrm>
           <a:prstGeom xmlns:a="http://schemas.openxmlformats.org/drawingml/2006/main" prst="roundRect">
             <a:avLst>
@@ -3781,7 +3968,7 @@
         <p:spPr>
           <a:xfrm xmlns:a="http://schemas.openxmlformats.org/drawingml/2006/main">
             <a:off x="5903119" y="4160996"/>
-            <a:ext cx="1169193" cy="552450"/>
+            <a:ext cx="1169194" cy="552450"/>
           </a:xfrm>
           <a:prstGeom xmlns:a="http://schemas.openxmlformats.org/drawingml/2006/main" prst="rect">
             <a:avLst/>
@@ -3794,7 +3981,7 @@
         </p:spPr>
         <p:txBody>
           <a:bodyPr xmlns:a="http://schemas.openxmlformats.org/drawingml/2006/main" wrap="square" lIns="19050" tIns="9525" rIns="19050" bIns="9525" anchor="ctr">
-            <a:normAutofit/>
+            <a:noAutofit/>
           </a:bodyPr>
           <a:lstStyle xmlns:a="http://schemas.openxmlformats.org/drawingml/2006/main"/>
           <a:p xmlns:a="http://schemas.openxmlformats.org/drawingml/2006/main">
@@ -3923,7 +4110,7 @@
         <p:spPr>
           <a:xfrm xmlns:a="http://schemas.openxmlformats.org/drawingml/2006/main">
             <a:off x="5874544" y="4895850"/>
-            <a:ext cx="1200150" cy="552450"/>
+            <a:ext cx="1200150" cy="609600"/>
           </a:xfrm>
           <a:prstGeom xmlns:a="http://schemas.openxmlformats.org/drawingml/2006/main" prst="roundRect">
             <a:avLst>
@@ -3965,7 +4152,7 @@
         <p:spPr>
           <a:xfrm xmlns:a="http://schemas.openxmlformats.org/drawingml/2006/main">
             <a:off x="5903119" y="4924425"/>
-            <a:ext cx="1143000" cy="495300"/>
+            <a:ext cx="1143000" cy="552450"/>
           </a:xfrm>
           <a:prstGeom xmlns:a="http://schemas.openxmlformats.org/drawingml/2006/main" prst="rect">
             <a:avLst/>
@@ -3978,7 +4165,7 @@
         </p:spPr>
         <p:txBody>
           <a:bodyPr xmlns:a="http://schemas.openxmlformats.org/drawingml/2006/main" wrap="square" lIns="19050" tIns="9525" rIns="19050" bIns="9525" anchor="ctr">
-            <a:normAutofit/>
+            <a:noAutofit/>
           </a:bodyPr>
           <a:lstStyle xmlns:a="http://schemas.openxmlformats.org/drawingml/2006/main"/>
           <a:p xmlns:a="http://schemas.openxmlformats.org/drawingml/2006/main">
@@ -3997,7 +4184,7 @@
               </a:defRPr>
             </a:pPr>
             <a:r>
-              <a:rPr sz="1125" b="1" i="0">
+              <a:rPr sz="1200" b="1" i="0">
                 <a:solidFill>
                   <a:srgbClr val="6D3504"/>
                 </a:solidFill>
@@ -4024,7 +4211,7 @@
               </a:defRPr>
             </a:pPr>
             <a:r>
-              <a:rPr sz="1125" b="1">
+              <a:rPr sz="1200" b="1">
                 <a:solidFill>
                   <a:srgbClr val="6D3504"/>
                 </a:solidFill>
@@ -4051,7 +4238,7 @@
               </a:defRPr>
             </a:pPr>
             <a:r>
-              <a:rPr sz="1125" b="1">
+              <a:rPr sz="1200" b="1">
                 <a:solidFill>
                   <a:srgbClr val="6D3504"/>
                 </a:solidFill>
@@ -4062,7 +4249,7 @@
               <a:t>c</a:t>
             </a:r>
             <a:r>
-              <a:rPr sz="1125" b="1" i="0">
+              <a:rPr sz="1200" b="1" i="0">
                 <a:solidFill>
                   <a:srgbClr val="6D3504"/>
                 </a:solidFill>
@@ -4313,7 +4500,7 @@
         </p:spPr>
         <p:txBody>
           <a:bodyPr xmlns:a="http://schemas.openxmlformats.org/drawingml/2006/main" wrap="square" lIns="19050" tIns="9525" rIns="19050" bIns="9525" anchor="ctr">
-            <a:normAutofit/>
+            <a:noAutofit/>
           </a:bodyPr>
           <a:lstStyle xmlns:a="http://schemas.openxmlformats.org/drawingml/2006/main"/>
           <a:p xmlns:a="http://schemas.openxmlformats.org/drawingml/2006/main">
@@ -4332,7 +4519,7 @@
               </a:defRPr>
             </a:pPr>
             <a:r>
-              <a:rPr sz="1575" b="1" i="0">
+              <a:rPr sz="1500" b="1" i="0">
                 <a:solidFill>
                   <a:srgbClr val="FFFFFF"/>
                 </a:solidFill>
@@ -4410,7 +4597,7 @@
         </p:spPr>
         <p:txBody>
           <a:bodyPr xmlns:a="http://schemas.openxmlformats.org/drawingml/2006/main" wrap="square" lIns="19050" tIns="9525" rIns="19050" bIns="9525" anchor="ctr">
-            <a:normAutofit/>
+            <a:noAutofit/>
           </a:bodyPr>
           <a:lstStyle xmlns:a="http://schemas.openxmlformats.org/drawingml/2006/main"/>
           <a:p xmlns:a="http://schemas.openxmlformats.org/drawingml/2006/main">
@@ -4603,7 +4790,7 @@
         </p:spPr>
         <p:txBody>
           <a:bodyPr xmlns:a="http://schemas.openxmlformats.org/drawingml/2006/main" wrap="square" lIns="19050" tIns="9525" rIns="19050" bIns="9525" anchor="ctr">
-            <a:normAutofit/>
+            <a:noAutofit/>
           </a:bodyPr>
           <a:lstStyle xmlns:a="http://schemas.openxmlformats.org/drawingml/2006/main"/>
           <a:p xmlns:a="http://schemas.openxmlformats.org/drawingml/2006/main">
@@ -4622,7 +4809,7 @@
               </a:defRPr>
             </a:pPr>
             <a:r>
-              <a:rPr sz="1800" b="1" i="0">
+              <a:rPr sz="1650" b="1" i="0">
                 <a:solidFill>
                   <a:srgbClr val="FFFFFF"/>
                 </a:solidFill>
@@ -4693,7 +4880,7 @@
         </p:nvSpPr>
         <p:spPr>
           <a:xfrm xmlns:a="http://schemas.openxmlformats.org/drawingml/2006/main">
-            <a:off x="7981950" y="4171950"/>
+            <a:off x="7981950" y="4383881"/>
             <a:ext cx="3562350" cy="471488"/>
           </a:xfrm>
           <a:prstGeom xmlns:a="http://schemas.openxmlformats.org/drawingml/2006/main" prst="rect">
@@ -4707,7 +4894,7 @@
         </p:spPr>
         <p:txBody>
           <a:bodyPr xmlns:a="http://schemas.openxmlformats.org/drawingml/2006/main" wrap="square" lIns="19050" tIns="9525" rIns="19050" bIns="9525" anchor="ctr">
-            <a:normAutofit/>
+            <a:noAutofit/>
           </a:bodyPr>
           <a:lstStyle xmlns:a="http://schemas.openxmlformats.org/drawingml/2006/main"/>
           <a:p xmlns:a="http://schemas.openxmlformats.org/drawingml/2006/main">
@@ -4726,7 +4913,7 @@
               </a:defRPr>
             </a:pPr>
             <a:r>
-              <a:rPr sz="2250" b="1" i="0">
+              <a:rPr sz="1950" b="1" i="0">
                 <a:solidFill>
                   <a:srgbClr val="FFFFFF"/>
                 </a:solidFill>
@@ -4735,68 +4922,6 @@
                 <a:cs typeface="Arial"/>
               </a:rPr>
               <a:t>RCPS(P,C)</a:t>
-            </a:r>
-          </a:p>
-        </p:txBody>
-      </p:sp>
-      <p:sp>
-        <p:nvSpPr>
-          <p:cNvPr id="79" name="rcps-score-subtitle">
-            <a:extLst xmlns:a="http://schemas.openxmlformats.org/drawingml/2006/main">
-              <a:ext uri="{FF2B5EF4-FFF2-40B4-BE49-F238E27FC236}">
-                <a16:creationId xmlns:a16="http://schemas.microsoft.com/office/drawing/2014/main" id="{DD1F15B6-03C6-99CA-454E-D7F58F817359}"/>
-              </a:ext>
-            </a:extLst>
-          </p:cNvPr>
-          <p:cNvSpPr>
-            <a:spLocks xmlns:a="http://schemas.openxmlformats.org/drawingml/2006/main" noGrp="1"/>
-          </p:cNvSpPr>
-          <p:nvPr/>
-        </p:nvSpPr>
-        <p:spPr>
-          <a:xfrm xmlns:a="http://schemas.openxmlformats.org/drawingml/2006/main">
-            <a:off x="7981950" y="4588193"/>
-            <a:ext cx="3562350" cy="450533"/>
-          </a:xfrm>
-          <a:prstGeom xmlns:a="http://schemas.openxmlformats.org/drawingml/2006/main" prst="rect">
-            <a:avLst/>
-          </a:prstGeom>
-          <a:noFill xmlns:a="http://schemas.openxmlformats.org/drawingml/2006/main"/>
-          <a:ln xmlns:a="http://schemas.openxmlformats.org/drawingml/2006/main" w="0">
-            <a:noFill/>
-            <a:prstDash val="solid"/>
-          </a:ln>
-        </p:spPr>
-        <p:txBody>
-          <a:bodyPr xmlns:a="http://schemas.openxmlformats.org/drawingml/2006/main" wrap="square" lIns="19050" tIns="9525" rIns="19050" bIns="9525" anchor="ctr">
-            <a:normAutofit/>
-          </a:bodyPr>
-          <a:lstStyle xmlns:a="http://schemas.openxmlformats.org/drawingml/2006/main"/>
-          <a:p xmlns:a="http://schemas.openxmlformats.org/drawingml/2006/main">
-            <a:pPr algn="ctr">
-              <a:lnSpc>
-                <a:spcPct val="95000"/>
-              </a:lnSpc>
-              <a:buNone/>
-              <a:defRPr sz="1350" b="0" i="0">
-                <a:solidFill>
-                  <a:srgbClr val="E4EDF3"/>
-                </a:solidFill>
-                <a:latin typeface="Arial"/>
-                <a:ea typeface="Arial"/>
-                <a:cs typeface="Arial"/>
-              </a:defRPr>
-            </a:pPr>
-            <a:r>
-              <a:rPr sz="1350" b="0" i="0">
-                <a:solidFill>
-                  <a:srgbClr val="E4EDF3"/>
-                </a:solidFill>
-                <a:latin typeface="Arial"/>
-                <a:ea typeface="Arial"/>
-                <a:cs typeface="Arial"/>
-              </a:rPr>
-              <a:t>mean MRR across retrievers and cutoffs</a:t>
             </a:r>
           </a:p>
         </p:txBody>
@@ -4914,8 +5039,8 @@
         </p:nvSpPr>
         <p:spPr>
           <a:xfrm xmlns:a="http://schemas.openxmlformats.org/drawingml/2006/main">
-            <a:off x="8048625" y="5476875"/>
-            <a:ext cx="3429000" cy="1285875"/>
+            <a:off x="7905750" y="5429250"/>
+            <a:ext cx="3714750" cy="1485900"/>
           </a:xfrm>
           <a:prstGeom xmlns:a="http://schemas.openxmlformats.org/drawingml/2006/main" prst="roundRect">
             <a:avLst>
@@ -4956,8 +5081,8 @@
         </p:nvSpPr>
         <p:spPr>
           <a:xfrm xmlns:a="http://schemas.openxmlformats.org/drawingml/2006/main">
-            <a:off x="8239125" y="5524500"/>
-            <a:ext cx="3048000" cy="323850"/>
+            <a:off x="8096250" y="5476875"/>
+            <a:ext cx="3333750" cy="323850"/>
           </a:xfrm>
           <a:prstGeom xmlns:a="http://schemas.openxmlformats.org/drawingml/2006/main" prst="rect">
             <a:avLst/>
@@ -4970,7 +5095,7 @@
         </p:spPr>
         <p:txBody>
           <a:bodyPr xmlns:a="http://schemas.openxmlformats.org/drawingml/2006/main" wrap="square" lIns="19050" tIns="9525" rIns="19050" bIns="9525" anchor="ctr">
-            <a:normAutofit/>
+            <a:normAutofit fontScale="100000"/>
           </a:bodyPr>
           <a:lstStyle xmlns:a="http://schemas.openxmlformats.org/drawingml/2006/main"/>
           <a:p xmlns:a="http://schemas.openxmlformats.org/drawingml/2006/main">
@@ -5018,8 +5143,8 @@
         </p:nvSpPr>
         <p:spPr>
           <a:xfrm xmlns:a="http://schemas.openxmlformats.org/drawingml/2006/main">
-            <a:off x="8201025" y="5915025"/>
-            <a:ext cx="1476375" cy="323850"/>
+            <a:off x="8058150" y="5905500"/>
+            <a:ext cx="1619250" cy="400050"/>
           </a:xfrm>
           <a:prstGeom xmlns:a="http://schemas.openxmlformats.org/drawingml/2006/main" prst="roundRect">
             <a:avLst>
@@ -5053,8 +5178,8 @@
         </p:nvSpPr>
         <p:spPr>
           <a:xfrm xmlns:a="http://schemas.openxmlformats.org/drawingml/2006/main">
-            <a:off x="8229600" y="5934075"/>
-            <a:ext cx="1419225" cy="285750"/>
+            <a:off x="8086725" y="5943600"/>
+            <a:ext cx="1562100" cy="323850"/>
           </a:xfrm>
           <a:prstGeom xmlns:a="http://schemas.openxmlformats.org/drawingml/2006/main" prst="rect">
             <a:avLst/>
@@ -5067,7 +5192,7 @@
         </p:spPr>
         <p:txBody>
           <a:bodyPr xmlns:a="http://schemas.openxmlformats.org/drawingml/2006/main" wrap="square" lIns="19050" tIns="9525" rIns="19050" bIns="9525" anchor="ctr">
-            <a:normAutofit/>
+            <a:normAutofit fontScale="100000"/>
           </a:bodyPr>
           <a:lstStyle xmlns:a="http://schemas.openxmlformats.org/drawingml/2006/main"/>
           <a:p xmlns:a="http://schemas.openxmlformats.org/drawingml/2006/main">
@@ -5115,8 +5240,8 @@
         </p:nvSpPr>
         <p:spPr>
           <a:xfrm xmlns:a="http://schemas.openxmlformats.org/drawingml/2006/main">
-            <a:off x="9848850" y="5915025"/>
-            <a:ext cx="1476375" cy="323850"/>
+            <a:off x="9848850" y="5905500"/>
+            <a:ext cx="1619250" cy="400050"/>
           </a:xfrm>
           <a:prstGeom xmlns:a="http://schemas.openxmlformats.org/drawingml/2006/main" prst="roundRect">
             <a:avLst>
@@ -5150,8 +5275,8 @@
         </p:nvSpPr>
         <p:spPr>
           <a:xfrm xmlns:a="http://schemas.openxmlformats.org/drawingml/2006/main">
-            <a:off x="9877425" y="5934075"/>
-            <a:ext cx="1419225" cy="285750"/>
+            <a:off x="9877425" y="5943600"/>
+            <a:ext cx="1562100" cy="323850"/>
           </a:xfrm>
           <a:prstGeom xmlns:a="http://schemas.openxmlformats.org/drawingml/2006/main" prst="rect">
             <a:avLst/>
@@ -5164,7 +5289,7 @@
         </p:spPr>
         <p:txBody>
           <a:bodyPr xmlns:a="http://schemas.openxmlformats.org/drawingml/2006/main" wrap="square" lIns="19050" tIns="9525" rIns="19050" bIns="9525" anchor="ctr">
-            <a:normAutofit/>
+            <a:normAutofit fontScale="100000"/>
           </a:bodyPr>
           <a:lstStyle xmlns:a="http://schemas.openxmlformats.org/drawingml/2006/main"/>
           <a:p xmlns:a="http://schemas.openxmlformats.org/drawingml/2006/main">
@@ -5212,8 +5337,8 @@
         </p:nvSpPr>
         <p:spPr>
           <a:xfrm xmlns:a="http://schemas.openxmlformats.org/drawingml/2006/main">
-            <a:off x="8201025" y="6334125"/>
-            <a:ext cx="1476375" cy="323850"/>
+            <a:off x="8058150" y="6419850"/>
+            <a:ext cx="1619250" cy="400050"/>
           </a:xfrm>
           <a:prstGeom xmlns:a="http://schemas.openxmlformats.org/drawingml/2006/main" prst="roundRect">
             <a:avLst>
@@ -5247,8 +5372,8 @@
         </p:nvSpPr>
         <p:spPr>
           <a:xfrm xmlns:a="http://schemas.openxmlformats.org/drawingml/2006/main">
-            <a:off x="8229600" y="6353175"/>
-            <a:ext cx="1419225" cy="285750"/>
+            <a:off x="8086725" y="6457950"/>
+            <a:ext cx="1562100" cy="323850"/>
           </a:xfrm>
           <a:prstGeom xmlns:a="http://schemas.openxmlformats.org/drawingml/2006/main" prst="rect">
             <a:avLst/>
@@ -5261,7 +5386,7 @@
         </p:spPr>
         <p:txBody>
           <a:bodyPr xmlns:a="http://schemas.openxmlformats.org/drawingml/2006/main" wrap="square" lIns="19050" tIns="9525" rIns="19050" bIns="9525" anchor="ctr">
-            <a:normAutofit/>
+            <a:normAutofit fontScale="100000"/>
           </a:bodyPr>
           <a:lstStyle xmlns:a="http://schemas.openxmlformats.org/drawingml/2006/main"/>
           <a:p xmlns:a="http://schemas.openxmlformats.org/drawingml/2006/main">
@@ -5288,7 +5413,29 @@
                 <a:ea typeface="Arial"/>
                 <a:cs typeface="Arial"/>
               </a:rPr>
-              <a:t>Cutoffs k = 1, 5, 10</a:t>
+              <a:t>Cutoffs </a:t>
+            </a:r>
+            <a:r>
+              <a:rPr sz="1125" b="1" i="1">
+                <a:solidFill>
+                  <a:srgbClr val="34566F"/>
+                </a:solidFill>
+                <a:latin typeface="Arial"/>
+                <a:ea typeface="Arial"/>
+                <a:cs typeface="Arial"/>
+              </a:rPr>
+              <a:t>k</a:t>
+            </a:r>
+            <a:r>
+              <a:rPr sz="1125" b="1" i="0">
+                <a:solidFill>
+                  <a:srgbClr val="34566F"/>
+                </a:solidFill>
+                <a:latin typeface="Arial"/>
+                <a:ea typeface="Arial"/>
+                <a:cs typeface="Arial"/>
+              </a:rPr>
+              <a:t> = 1, 5, 10</a:t>
             </a:r>
           </a:p>
         </p:txBody>
@@ -5309,8 +5456,8 @@
         </p:nvSpPr>
         <p:spPr>
           <a:xfrm xmlns:a="http://schemas.openxmlformats.org/drawingml/2006/main">
-            <a:off x="9848850" y="6334125"/>
-            <a:ext cx="1476375" cy="323850"/>
+            <a:off x="9848850" y="6419850"/>
+            <a:ext cx="1619250" cy="400050"/>
           </a:xfrm>
           <a:prstGeom xmlns:a="http://schemas.openxmlformats.org/drawingml/2006/main" prst="roundRect">
             <a:avLst>
@@ -5344,8 +5491,8 @@
         </p:nvSpPr>
         <p:spPr>
           <a:xfrm xmlns:a="http://schemas.openxmlformats.org/drawingml/2006/main">
-            <a:off x="9877425" y="6353175"/>
-            <a:ext cx="1419225" cy="285750"/>
+            <a:off x="9877425" y="6457950"/>
+            <a:ext cx="1562100" cy="323850"/>
           </a:xfrm>
           <a:prstGeom xmlns:a="http://schemas.openxmlformats.org/drawingml/2006/main" prst="rect">
             <a:avLst/>
@@ -5358,7 +5505,7 @@
         </p:spPr>
         <p:txBody>
           <a:bodyPr xmlns:a="http://schemas.openxmlformats.org/drawingml/2006/main" wrap="square" lIns="19050" tIns="9525" rIns="19050" bIns="9525" anchor="ctr">
-            <a:normAutofit/>
+            <a:normAutofit fontScale="100000"/>
           </a:bodyPr>
           <a:lstStyle xmlns:a="http://schemas.openxmlformats.org/drawingml/2006/main"/>
           <a:p xmlns:a="http://schemas.openxmlformats.org/drawingml/2006/main">
@@ -5460,7 +5607,7 @@
         </p:spPr>
         <p:txBody>
           <a:bodyPr xmlns:a="http://schemas.openxmlformats.org/drawingml/2006/main" wrap="square" lIns="19050" tIns="9525" rIns="19050" bIns="9525" anchor="ctr">
-            <a:normAutofit/>
+            <a:noAutofit/>
           </a:bodyPr>
           <a:lstStyle xmlns:a="http://schemas.openxmlformats.org/drawingml/2006/main"/>
           <a:p xmlns:a="http://schemas.openxmlformats.org/drawingml/2006/main">
@@ -5479,7 +5626,7 @@
               </a:defRPr>
             </a:pPr>
             <a:r>
-              <a:rPr sz="1575" b="1" i="0">
+              <a:rPr sz="1500" b="1" i="0">
                 <a:solidFill>
                   <a:srgbClr val="FFFFFF"/>
                 </a:solidFill>
@@ -5522,7 +5669,7 @@
         </p:spPr>
         <p:txBody>
           <a:bodyPr xmlns:a="http://schemas.openxmlformats.org/drawingml/2006/main" wrap="square" lIns="19050" tIns="9525" rIns="19050" bIns="9525" anchor="ctr">
-            <a:normAutofit/>
+            <a:noAutofit/>
           </a:bodyPr>
           <a:lstStyle xmlns:a="http://schemas.openxmlformats.org/drawingml/2006/main"/>
           <a:p xmlns:a="http://schemas.openxmlformats.org/drawingml/2006/main">
@@ -5541,7 +5688,7 @@
               </a:defRPr>
             </a:pPr>
             <a:r>
-              <a:rPr sz="1275" b="0" i="0">
+              <a:rPr sz="1200" b="0" i="0">
                 <a:solidFill>
                   <a:srgbClr val="E4EDF3"/>
                 </a:solidFill>
@@ -5549,7 +5696,40 @@
                 <a:ea typeface="Arial"/>
                 <a:cs typeface="Arial"/>
               </a:rPr>
-              <a:t>one score for every P_i x C_j</a:t>
+              <a:t>one score for every </a:t>
+            </a:r>
+            <a:r>
+              <a:rPr sz="1200" b="0" i="1">
+                <a:solidFill>
+                  <a:srgbClr val="E4EDF3"/>
+                </a:solidFill>
+                <a:latin typeface="Arial"/>
+                <a:ea typeface="Arial"/>
+                <a:cs typeface="Arial"/>
+              </a:rPr>
+              <a:t>Pᵢ</a:t>
+            </a:r>
+            <a:r>
+              <a:rPr sz="1200" b="0" i="0">
+                <a:solidFill>
+                  <a:srgbClr val="E4EDF3"/>
+                </a:solidFill>
+                <a:latin typeface="Arial"/>
+                <a:ea typeface="Arial"/>
+                <a:cs typeface="Arial"/>
+              </a:rPr>
+              <a:t> × </a:t>
+            </a:r>
+            <a:r>
+              <a:rPr sz="1200" b="0" i="1">
+                <a:solidFill>
+                  <a:srgbClr val="E4EDF3"/>
+                </a:solidFill>
+                <a:latin typeface="Arial"/>
+                <a:ea typeface="Arial"/>
+                <a:cs typeface="Arial"/>
+              </a:rPr>
+              <a:t>Cⱼ</a:t>
             </a:r>
           </a:p>
         </p:txBody>
@@ -5701,7 +5881,7 @@
         </p:spPr>
         <p:txBody>
           <a:bodyPr xmlns:a="http://schemas.openxmlformats.org/drawingml/2006/main" wrap="square" lIns="19050" tIns="9525" rIns="19050" bIns="9525" anchor="ctr">
-            <a:normAutofit/>
+            <a:noAutofit/>
           </a:bodyPr>
           <a:lstStyle xmlns:a="http://schemas.openxmlformats.org/drawingml/2006/main"/>
           <a:p xmlns:a="http://schemas.openxmlformats.org/drawingml/2006/main">
@@ -5720,7 +5900,7 @@
               </a:defRPr>
             </a:pPr>
             <a:r>
-              <a:rPr sz="1575" b="1" i="0">
+              <a:rPr sz="1500" b="1" i="0">
                 <a:solidFill>
                   <a:srgbClr val="FFFFFF"/>
                 </a:solidFill>
@@ -6454,7 +6634,7 @@
         </p:spPr>
         <p:txBody>
           <a:bodyPr xmlns:a="http://schemas.openxmlformats.org/drawingml/2006/main" wrap="square" lIns="19050" tIns="9525" rIns="19050" bIns="9525" anchor="ctr">
-            <a:normAutofit/>
+            <a:normAutofit fontScale="100000"/>
           </a:bodyPr>
           <a:lstStyle xmlns:a="http://schemas.openxmlformats.org/drawingml/2006/main"/>
           <a:p xmlns:a="http://schemas.openxmlformats.org/drawingml/2006/main">
@@ -6473,6 +6653,17 @@
               </a:defRPr>
             </a:pPr>
             <a:r>
+              <a:rPr sz="1275" b="1" i="1">
+                <a:solidFill>
+                  <a:srgbClr val="075129"/>
+                </a:solidFill>
+                <a:latin typeface="Arial"/>
+                <a:ea typeface="Arial"/>
+                <a:cs typeface="Arial"/>
+              </a:rPr>
+              <a:t>C₁</a:t>
+            </a:r>
+            <a:r>
               <a:rPr sz="1275" b="1" i="0">
                 <a:solidFill>
                   <a:srgbClr val="075129"/>
@@ -6481,7 +6672,18 @@
                 <a:ea typeface="Arial"/>
                 <a:cs typeface="Arial"/>
               </a:rPr>
-              <a:t>C_1      ...      </a:t>
+              <a:t>      ⋯      </a:t>
+            </a:r>
+            <a:r>
+              <a:rPr sz="1275" b="1" i="1">
+                <a:solidFill>
+                  <a:srgbClr val="075129"/>
+                </a:solidFill>
+                <a:latin typeface="Arial"/>
+                <a:ea typeface="Arial"/>
+                <a:cs typeface="Arial"/>
+              </a:rPr>
+              <a:t>Cⱼ</a:t>
             </a:r>
             <a:r>
               <a:rPr sz="1275" b="1" i="0">
@@ -6492,10 +6694,10 @@
                 <a:ea typeface="Arial"/>
                 <a:cs typeface="Arial"/>
               </a:rPr>
-              <a:t>C_j</a:t>
-            </a:r>
-            <a:r>
-              <a:rPr sz="1275" b="1" i="0">
+              <a:t>      ⋯      </a:t>
+            </a:r>
+            <a:r>
+              <a:rPr sz="1275" b="1" i="1">
                 <a:solidFill>
                   <a:srgbClr val="075129"/>
                 </a:solidFill>
@@ -6503,18 +6705,7 @@
                 <a:ea typeface="Arial"/>
                 <a:cs typeface="Arial"/>
               </a:rPr>
-              <a:t>      ...      </a:t>
-            </a:r>
-            <a:r>
-              <a:rPr sz="1275" b="1" i="0">
-                <a:solidFill>
-                  <a:srgbClr val="075129"/>
-                </a:solidFill>
-                <a:latin typeface="Arial"/>
-                <a:ea typeface="Arial"/>
-                <a:cs typeface="Arial"/>
-              </a:rPr>
-              <a:t>C_c</a:t>
+              <a:t>C꜀</a:t>
             </a:r>
             <a:endParaRPr sz="1275" b="1" i="0">
               <a:solidFill>
@@ -6576,7 +6767,7 @@
               </a:defRPr>
             </a:pPr>
             <a:r>
-              <a:rPr sz="1275" b="1" i="0">
+              <a:rPr sz="1275" b="1" i="1">
                 <a:solidFill>
                   <a:srgbClr val="1B5A95"/>
                 </a:solidFill>
@@ -6584,7 +6775,7 @@
                 <a:ea typeface="Arial"/>
                 <a:cs typeface="Arial"/>
               </a:rPr>
-              <a:t>P_1</a:t>
+              <a:t>P₁</a:t>
             </a:r>
             <a:endParaRPr sz="1275" b="1" i="0">
               <a:solidFill>
@@ -6619,7 +6810,7 @@
                 <a:ea typeface="Arial"/>
                 <a:cs typeface="Arial"/>
               </a:rPr>
-              <a:t>...</a:t>
+              <a:t>⋮</a:t>
             </a:r>
             <a:endParaRPr sz="1275" b="1" i="0">
               <a:solidFill>
@@ -6646,7 +6837,7 @@
               </a:defRPr>
             </a:pPr>
             <a:r>
-              <a:rPr sz="1275" b="1" i="0">
+              <a:rPr sz="1275" b="1" i="1">
                 <a:solidFill>
                   <a:srgbClr val="1B5A95"/>
                 </a:solidFill>
@@ -6654,7 +6845,7 @@
                 <a:ea typeface="Arial"/>
                 <a:cs typeface="Arial"/>
               </a:rPr>
-              <a:t>P_i</a:t>
+              <a:t>Pᵢ</a:t>
             </a:r>
             <a:endParaRPr sz="1275" b="1" i="0">
               <a:solidFill>
@@ -6689,7 +6880,7 @@
                 <a:ea typeface="Arial"/>
                 <a:cs typeface="Arial"/>
               </a:rPr>
-              <a:t>...</a:t>
+              <a:t>⋮</a:t>
             </a:r>
             <a:endParaRPr sz="1275" b="1" i="0">
               <a:solidFill>
@@ -6716,7 +6907,7 @@
               </a:defRPr>
             </a:pPr>
             <a:r>
-              <a:rPr sz="1275" b="1" i="0">
+              <a:rPr sz="1275" b="1" i="1">
                 <a:solidFill>
                   <a:srgbClr val="1B5A95"/>
                 </a:solidFill>
@@ -6724,7 +6915,7 @@
                 <a:ea typeface="Arial"/>
                 <a:cs typeface="Arial"/>
               </a:rPr>
-              <a:t>P_m</a:t>
+              <a:t>Pₘ</a:t>
             </a:r>
             <a:endParaRPr sz="1275" b="1" i="0">
               <a:solidFill>
@@ -6753,8 +6944,8 @@
         </p:nvSpPr>
         <p:spPr>
           <a:xfrm xmlns:a="http://schemas.openxmlformats.org/drawingml/2006/main">
-            <a:off x="12525375" y="3390900"/>
-            <a:ext cx="3143250" cy="342900"/>
+            <a:off x="12382500" y="3390900"/>
+            <a:ext cx="3429000" cy="342900"/>
           </a:xfrm>
           <a:prstGeom xmlns:a="http://schemas.openxmlformats.org/drawingml/2006/main" prst="roundRect">
             <a:avLst>
@@ -6788,8 +6979,8 @@
         </p:nvSpPr>
         <p:spPr>
           <a:xfrm xmlns:a="http://schemas.openxmlformats.org/drawingml/2006/main">
-            <a:off x="12553950" y="3409950"/>
-            <a:ext cx="3086100" cy="304800"/>
+            <a:off x="12411075" y="3409950"/>
+            <a:ext cx="3371850" cy="304800"/>
           </a:xfrm>
           <a:prstGeom xmlns:a="http://schemas.openxmlformats.org/drawingml/2006/main" prst="rect">
             <a:avLst/>
@@ -6802,7 +6993,7 @@
         </p:spPr>
         <p:txBody>
           <a:bodyPr xmlns:a="http://schemas.openxmlformats.org/drawingml/2006/main" wrap="square" lIns="19050" tIns="9525" rIns="19050" bIns="9525" anchor="ctr">
-            <a:normAutofit/>
+            <a:normAutofit fontScale="100000"/>
           </a:bodyPr>
           <a:lstStyle xmlns:a="http://schemas.openxmlformats.org/drawingml/2006/main"/>
           <a:p xmlns:a="http://schemas.openxmlformats.org/drawingml/2006/main">
@@ -6829,7 +7020,7 @@
                 <a:ea typeface="Arial"/>
                 <a:cs typeface="Arial"/>
               </a:rPr>
-              <a:t>RCPS rank | latency/compute tie-break</a:t>
+              <a:t>Rank by RCPS; latency/compute decide ties</a:t>
             </a:r>
           </a:p>
         </p:txBody>
@@ -7363,8 +7554,8 @@
         </p:nvSpPr>
         <p:spPr>
           <a:xfrm xmlns:a="http://schemas.openxmlformats.org/drawingml/2006/main">
-            <a:off x="12592050" y="5295900"/>
-            <a:ext cx="3009900" cy="609600"/>
+            <a:off x="12382500" y="5295900"/>
+            <a:ext cx="3429000" cy="609600"/>
           </a:xfrm>
           <a:prstGeom xmlns:a="http://schemas.openxmlformats.org/drawingml/2006/main" prst="roundRect">
             <a:avLst>
@@ -7405,8 +7596,8 @@
         </p:nvSpPr>
         <p:spPr>
           <a:xfrm xmlns:a="http://schemas.openxmlformats.org/drawingml/2006/main">
-            <a:off x="12668250" y="5372100"/>
-            <a:ext cx="2857500" cy="274320"/>
+            <a:off x="12458700" y="5372100"/>
+            <a:ext cx="3276600" cy="274320"/>
           </a:xfrm>
           <a:prstGeom xmlns:a="http://schemas.openxmlformats.org/drawingml/2006/main" prst="rect">
             <a:avLst/>
@@ -7419,7 +7610,7 @@
         </p:spPr>
         <p:txBody>
           <a:bodyPr xmlns:a="http://schemas.openxmlformats.org/drawingml/2006/main" wrap="square" lIns="19050" tIns="9525" rIns="19050" bIns="9525" anchor="ctr">
-            <a:normAutofit/>
+            <a:normAutofit fontScale="100000"/>
           </a:bodyPr>
           <a:lstStyle xmlns:a="http://schemas.openxmlformats.org/drawingml/2006/main"/>
           <a:p xmlns:a="http://schemas.openxmlformats.org/drawingml/2006/main">
@@ -7467,8 +7658,8 @@
         </p:nvSpPr>
         <p:spPr>
           <a:xfrm xmlns:a="http://schemas.openxmlformats.org/drawingml/2006/main">
-            <a:off x="12668250" y="5582412"/>
-            <a:ext cx="2857500" cy="262128"/>
+            <a:off x="12458700" y="5582412"/>
+            <a:ext cx="3276600" cy="262128"/>
           </a:xfrm>
           <a:prstGeom xmlns:a="http://schemas.openxmlformats.org/drawingml/2006/main" prst="rect">
             <a:avLst/>
@@ -7481,7 +7672,7 @@
         </p:spPr>
         <p:txBody>
           <a:bodyPr xmlns:a="http://schemas.openxmlformats.org/drawingml/2006/main" wrap="square" lIns="19050" tIns="9525" rIns="19050" bIns="9525" anchor="ctr">
-            <a:normAutofit/>
+            <a:normAutofit fontScale="100000"/>
           </a:bodyPr>
           <a:lstStyle xmlns:a="http://schemas.openxmlformats.org/drawingml/2006/main"/>
           <a:p xmlns:a="http://schemas.openxmlformats.org/drawingml/2006/main">
@@ -7508,7 +7699,7 @@
                 <a:ea typeface="Arial"/>
                 <a:cs typeface="Arial"/>
               </a:rPr>
-              <a:t>retriever-free exact-span check</a:t>
+              <a:t>Exact-span check, no retriever</a:t>
             </a:r>
           </a:p>
         </p:txBody>
@@ -7529,7 +7720,7 @@
         </p:nvSpPr>
         <p:spPr>
           <a:xfrm xmlns:a="http://schemas.openxmlformats.org/drawingml/2006/main">
-            <a:off x="15367318" y="5240655"/>
+            <a:off x="15576899" y="5240655"/>
             <a:ext cx="342900" cy="342900"/>
           </a:xfrm>
           <a:prstGeom xmlns:a="http://schemas.openxmlformats.org/drawingml/2006/main" prst="roundRect">
@@ -7571,7 +7762,7 @@
         </p:nvSpPr>
         <p:spPr>
           <a:xfrm xmlns:a="http://schemas.openxmlformats.org/drawingml/2006/main">
-            <a:off x="15386368" y="5259705"/>
+            <a:off x="15595949" y="5259705"/>
             <a:ext cx="304800" cy="304800"/>
           </a:xfrm>
           <a:prstGeom xmlns:a="http://schemas.openxmlformats.org/drawingml/2006/main" prst="rect">
@@ -8186,7 +8377,7 @@
         </p:spPr>
         <p:txBody>
           <a:bodyPr xmlns:a="http://schemas.openxmlformats.org/drawingml/2006/main" wrap="square" lIns="19050" tIns="9525" rIns="19050" bIns="9525" anchor="ctr">
-            <a:normAutofit/>
+            <a:normAutofit fontScale="100000"/>
           </a:bodyPr>
           <a:lstStyle xmlns:a="http://schemas.openxmlformats.org/drawingml/2006/main"/>
           <a:p xmlns:a="http://schemas.openxmlformats.org/drawingml/2006/main">
@@ -8213,34 +8404,7 @@
                 <a:ea typeface="Arial"/>
                 <a:cs typeface="Arial"/>
               </a:rPr>
-              <a:t>Inspect /</a:t>
-            </a:r>
-          </a:p>
-          <a:p xmlns:a="http://schemas.openxmlformats.org/drawingml/2006/main">
-            <a:pPr algn="ctr">
-              <a:lnSpc>
-                <a:spcPct val="95000"/>
-              </a:lnSpc>
-              <a:buNone/>
-              <a:defRPr sz="1200" b="1" i="0">
-                <a:solidFill>
-                  <a:srgbClr val="7D3C05"/>
-                </a:solidFill>
-                <a:latin typeface="Arial"/>
-                <a:ea typeface="Arial"/>
-                <a:cs typeface="Arial"/>
-              </a:defRPr>
-            </a:pPr>
-            <a:r>
-              <a:rPr sz="1200" b="1" i="0">
-                <a:solidFill>
-                  <a:srgbClr val="7D3C05"/>
-                </a:solidFill>
-                <a:latin typeface="Arial"/>
-                <a:ea typeface="Arial"/>
-                <a:cs typeface="Arial"/>
-              </a:rPr>
-              <a:t>switch P</a:t>
+              <a:t>Inspect parser</a:t>
             </a:r>
           </a:p>
         </p:txBody>
@@ -8310,7 +8474,7 @@
         </p:spPr>
         <p:txBody>
           <a:bodyPr xmlns:a="http://schemas.openxmlformats.org/drawingml/2006/main" wrap="square" lIns="19050" tIns="9525" rIns="19050" bIns="9525" anchor="ctr">
-            <a:normAutofit/>
+            <a:normAutofit fontScale="100000"/>
           </a:bodyPr>
           <a:lstStyle xmlns:a="http://schemas.openxmlformats.org/drawingml/2006/main"/>
           <a:p xmlns:a="http://schemas.openxmlformats.org/drawingml/2006/main">
@@ -8407,7 +8571,7 @@
         </p:spPr>
         <p:txBody>
           <a:bodyPr xmlns:a="http://schemas.openxmlformats.org/drawingml/2006/main" wrap="square" lIns="19050" tIns="9525" rIns="19050" bIns="9525" anchor="ctr">
-            <a:normAutofit/>
+            <a:normAutofit fontScale="100000"/>
           </a:bodyPr>
           <a:lstStyle xmlns:a="http://schemas.openxmlformats.org/drawingml/2006/main"/>
           <a:p xmlns:a="http://schemas.openxmlformats.org/drawingml/2006/main">
@@ -8434,34 +8598,7 @@
                 <a:ea typeface="Arial"/>
                 <a:cs typeface="Arial"/>
               </a:rPr>
-              <a:t>Overlap /</a:t>
-            </a:r>
-          </a:p>
-          <a:p xmlns:a="http://schemas.openxmlformats.org/drawingml/2006/main">
-            <a:pPr algn="ctr">
-              <a:lnSpc>
-                <a:spcPct val="95000"/>
-              </a:lnSpc>
-              <a:buNone/>
-              <a:defRPr sz="1200" b="1" i="0">
-                <a:solidFill>
-                  <a:srgbClr val="155755"/>
-                </a:solidFill>
-                <a:latin typeface="Arial"/>
-                <a:ea typeface="Arial"/>
-                <a:cs typeface="Arial"/>
-              </a:defRPr>
-            </a:pPr>
-            <a:r>
-              <a:rPr sz="1200" b="1" i="0">
-                <a:solidFill>
-                  <a:srgbClr val="155755"/>
-                </a:solidFill>
-                <a:latin typeface="Arial"/>
-                <a:ea typeface="Arial"/>
-                <a:cs typeface="Arial"/>
-              </a:rPr>
-              <a:t>rechunk</a:t>
+              <a:t>Rechunk</a:t>
             </a:r>
           </a:p>
         </p:txBody>
@@ -8865,7 +9002,7 @@
       </p:sp>
       <p:cxnSp>
         <p:nvCxnSpPr>
-          <p:cNvPr id="2576" name="직선 화살표 연결선 828"/>
+          <p:cNvPr id="5856" name="직선 화살표 연결선 828"/>
           <p:cNvCxnSpPr>
             <a:stCxn xmlns:a="http://schemas.openxmlformats.org/drawingml/2006/main" id="160" idx="3"/>
             <a:endCxn xmlns:a="http://schemas.openxmlformats.org/drawingml/2006/main" id="161" idx="1"/>
@@ -8880,7 +9017,7 @@
           <a:prstGeom xmlns:a="http://schemas.openxmlformats.org/drawingml/2006/main" prst="straightConnector1">
             <a:avLst/>
           </a:prstGeom>
-          <a:ln xmlns:a="http://schemas.openxmlformats.org/drawingml/2006/main" w="20955" cap="rnd">
+          <a:ln xmlns:a="http://schemas.openxmlformats.org/drawingml/2006/main" w="16193" cap="rnd">
             <a:solidFill>
               <a:srgbClr val="1D2B36"/>
             </a:solidFill>
@@ -8893,7 +9030,7 @@
       </p:cxnSp>
       <p:cxnSp>
         <p:nvCxnSpPr>
-          <p:cNvPr id="2577" name="직선 화살표 연결선 829"/>
+          <p:cNvPr id="5857" name="직선 화살표 연결선 829"/>
           <p:cNvCxnSpPr>
             <a:stCxn xmlns:a="http://schemas.openxmlformats.org/drawingml/2006/main" id="30" idx="2"/>
             <a:endCxn xmlns:a="http://schemas.openxmlformats.org/drawingml/2006/main" id="33" idx="0"/>
@@ -8902,13 +9039,13 @@
         </p:nvCxnSpPr>
         <p:spPr>
           <a:xfrm xmlns:a="http://schemas.openxmlformats.org/drawingml/2006/main">
-            <a:off x="4595813" y="1790700"/>
-            <a:ext cx="0" cy="323850"/>
+            <a:off x="4595813" y="1752600"/>
+            <a:ext cx="0" cy="342900"/>
           </a:xfrm>
           <a:prstGeom xmlns:a="http://schemas.openxmlformats.org/drawingml/2006/main" prst="straightConnector1">
             <a:avLst/>
           </a:prstGeom>
-          <a:ln xmlns:a="http://schemas.openxmlformats.org/drawingml/2006/main" w="19050" cap="rnd">
+          <a:ln xmlns:a="http://schemas.openxmlformats.org/drawingml/2006/main" w="16193" cap="rnd">
             <a:solidFill>
               <a:srgbClr val="1D2B36"/>
             </a:solidFill>
@@ -8921,7 +9058,7 @@
       </p:cxnSp>
       <p:cxnSp>
         <p:nvCxnSpPr>
-          <p:cNvPr id="2578" name="직선 화살표 연결선 830"/>
+          <p:cNvPr id="5858" name="직선 화살표 연결선 830"/>
           <p:cNvCxnSpPr>
             <a:stCxn xmlns:a="http://schemas.openxmlformats.org/drawingml/2006/main" id="33" idx="2"/>
             <a:endCxn xmlns:a="http://schemas.openxmlformats.org/drawingml/2006/main" id="35" idx="0"/>
@@ -8930,13 +9067,13 @@
         </p:nvCxnSpPr>
         <p:spPr>
           <a:xfrm xmlns:a="http://schemas.openxmlformats.org/drawingml/2006/main">
-            <a:off x="4595813" y="2819400"/>
-            <a:ext cx="0" cy="342900"/>
+            <a:off x="4595813" y="2838450"/>
+            <a:ext cx="0" cy="323850"/>
           </a:xfrm>
           <a:prstGeom xmlns:a="http://schemas.openxmlformats.org/drawingml/2006/main" prst="straightConnector1">
             <a:avLst/>
           </a:prstGeom>
-          <a:ln xmlns:a="http://schemas.openxmlformats.org/drawingml/2006/main" w="19050" cap="rnd">
+          <a:ln xmlns:a="http://schemas.openxmlformats.org/drawingml/2006/main" w="16193" cap="rnd">
             <a:solidFill>
               <a:srgbClr val="1D2B36"/>
             </a:solidFill>
@@ -8949,7 +9086,7 @@
       </p:cxnSp>
       <p:cxnSp>
         <p:nvCxnSpPr>
-          <p:cNvPr id="2579" name="직선 화살표 연결선 831"/>
+          <p:cNvPr id="5859" name="직선 화살표 연결선 831"/>
           <p:cNvCxnSpPr>
             <a:stCxn xmlns:a="http://schemas.openxmlformats.org/drawingml/2006/main" id="35" idx="2"/>
             <a:endCxn xmlns:a="http://schemas.openxmlformats.org/drawingml/2006/main" id="38" idx="0"/>
@@ -8964,7 +9101,7 @@
           <a:prstGeom xmlns:a="http://schemas.openxmlformats.org/drawingml/2006/main" prst="straightConnector1">
             <a:avLst/>
           </a:prstGeom>
-          <a:ln xmlns:a="http://schemas.openxmlformats.org/drawingml/2006/main" w="19050" cap="rnd">
+          <a:ln xmlns:a="http://schemas.openxmlformats.org/drawingml/2006/main" w="16193" cap="rnd">
             <a:solidFill>
               <a:srgbClr val="1D2B36"/>
             </a:solidFill>
@@ -8977,7 +9114,7 @@
       </p:cxnSp>
       <p:cxnSp>
         <p:nvCxnSpPr>
-          <p:cNvPr id="2580" name="직선 화살표 연결선 832"/>
+          <p:cNvPr id="5860" name="직선 화살표 연결선 832"/>
           <p:cNvCxnSpPr>
             <a:stCxn xmlns:a="http://schemas.openxmlformats.org/drawingml/2006/main" id="38" idx="2"/>
             <a:endCxn xmlns:a="http://schemas.openxmlformats.org/drawingml/2006/main" id="40" idx="0"/>
@@ -8992,7 +9129,7 @@
           <a:prstGeom xmlns:a="http://schemas.openxmlformats.org/drawingml/2006/main" prst="straightConnector1">
             <a:avLst/>
           </a:prstGeom>
-          <a:ln xmlns:a="http://schemas.openxmlformats.org/drawingml/2006/main" w="19050" cap="rnd">
+          <a:ln xmlns:a="http://schemas.openxmlformats.org/drawingml/2006/main" w="16193" cap="rnd">
             <a:solidFill>
               <a:srgbClr val="1D2B36"/>
             </a:solidFill>
@@ -9005,7 +9142,7 @@
       </p:cxnSp>
       <p:cxnSp>
         <p:nvCxnSpPr>
-          <p:cNvPr id="2581" name="직선 화살표 연결선 833"/>
+          <p:cNvPr id="5861" name="직선 화살표 연결선 833"/>
           <p:cNvCxnSpPr>
             <a:stCxn xmlns:a="http://schemas.openxmlformats.org/drawingml/2006/main" id="40" idx="2"/>
             <a:endCxn xmlns:a="http://schemas.openxmlformats.org/drawingml/2006/main" id="43" idx="0"/>
@@ -9014,13 +9151,13 @@
         </p:nvCxnSpPr>
         <p:spPr>
           <a:xfrm xmlns:a="http://schemas.openxmlformats.org/drawingml/2006/main">
-            <a:off x="4595813" y="6010275"/>
-            <a:ext cx="0" cy="657225"/>
+            <a:off x="4595813" y="5972175"/>
+            <a:ext cx="0" cy="695325"/>
           </a:xfrm>
           <a:prstGeom xmlns:a="http://schemas.openxmlformats.org/drawingml/2006/main" prst="straightConnector1">
             <a:avLst/>
           </a:prstGeom>
-          <a:ln xmlns:a="http://schemas.openxmlformats.org/drawingml/2006/main" w="19050" cap="rnd">
+          <a:ln xmlns:a="http://schemas.openxmlformats.org/drawingml/2006/main" w="16193" cap="rnd">
             <a:solidFill>
               <a:srgbClr val="1D2B36"/>
             </a:solidFill>
@@ -9076,7 +9213,7 @@
         </p:nvSpPr>
         <p:spPr>
           <a:xfrm xmlns:a="http://schemas.openxmlformats.org/drawingml/2006/main">
-            <a:off x="7515225" y="7153275"/>
+            <a:off x="7658100" y="7124700"/>
             <a:ext cx="19050" cy="19050"/>
           </a:xfrm>
           <a:prstGeom xmlns:a="http://schemas.openxmlformats.org/drawingml/2006/main" prst="rect">
@@ -9105,7 +9242,7 @@
         </p:nvSpPr>
         <p:spPr>
           <a:xfrm xmlns:a="http://schemas.openxmlformats.org/drawingml/2006/main">
-            <a:off x="7515225" y="1095375"/>
+            <a:off x="7658100" y="1095375"/>
             <a:ext cx="19050" cy="19050"/>
           </a:xfrm>
           <a:prstGeom xmlns:a="http://schemas.openxmlformats.org/drawingml/2006/main" prst="rect">
@@ -9163,7 +9300,7 @@
         </p:nvSpPr>
         <p:spPr>
           <a:xfrm xmlns:a="http://schemas.openxmlformats.org/drawingml/2006/main">
-            <a:off x="2914650" y="6467475"/>
+            <a:off x="2838450" y="6467475"/>
             <a:ext cx="19050" cy="19050"/>
           </a:xfrm>
           <a:prstGeom xmlns:a="http://schemas.openxmlformats.org/drawingml/2006/main" prst="rect">
@@ -9265,7 +9402,7 @@
       </p:sp>
       <p:cxnSp>
         <p:nvCxnSpPr>
-          <p:cNvPr id="2590" name="직선 화살표 연결선 852"/>
+          <p:cNvPr id="5870" name="직선 화살표 연결선 852"/>
           <p:cNvCxnSpPr>
             <a:stCxn xmlns:a="http://schemas.openxmlformats.org/drawingml/2006/main" id="62" idx="2"/>
             <a:endCxn xmlns:a="http://schemas.openxmlformats.org/drawingml/2006/main" id="72" idx="0"/>
@@ -9280,7 +9417,7 @@
           <a:prstGeom xmlns:a="http://schemas.openxmlformats.org/drawingml/2006/main" prst="straightConnector1">
             <a:avLst/>
           </a:prstGeom>
-          <a:ln xmlns:a="http://schemas.openxmlformats.org/drawingml/2006/main" w="19050" cap="rnd">
+          <a:ln xmlns:a="http://schemas.openxmlformats.org/drawingml/2006/main" w="16193" cap="rnd">
             <a:solidFill>
               <a:srgbClr val="1D2B36"/>
             </a:solidFill>
@@ -9293,7 +9430,7 @@
       </p:cxnSp>
       <p:cxnSp>
         <p:nvCxnSpPr>
-          <p:cNvPr id="2591" name="직선 화살표 연결선 853"/>
+          <p:cNvPr id="5871" name="직선 화살표 연결선 853"/>
           <p:cNvCxnSpPr>
             <a:stCxn xmlns:a="http://schemas.openxmlformats.org/drawingml/2006/main" id="72" idx="2"/>
             <a:endCxn xmlns:a="http://schemas.openxmlformats.org/drawingml/2006/main" id="75" idx="0"/>
@@ -9308,7 +9445,7 @@
           <a:prstGeom xmlns:a="http://schemas.openxmlformats.org/drawingml/2006/main" prst="straightConnector1">
             <a:avLst/>
           </a:prstGeom>
-          <a:ln xmlns:a="http://schemas.openxmlformats.org/drawingml/2006/main" w="19050" cap="rnd">
+          <a:ln xmlns:a="http://schemas.openxmlformats.org/drawingml/2006/main" w="16193" cap="rnd">
             <a:solidFill>
               <a:srgbClr val="1D2B36"/>
             </a:solidFill>
@@ -9321,7 +9458,7 @@
       </p:cxnSp>
       <p:cxnSp>
         <p:nvCxnSpPr>
-          <p:cNvPr id="2592" name="직선 화살표 연결선 854"/>
+          <p:cNvPr id="5872" name="직선 화살표 연결선 854"/>
           <p:cNvCxnSpPr>
             <a:stCxn xmlns:a="http://schemas.openxmlformats.org/drawingml/2006/main" id="75" idx="2"/>
             <a:endCxn xmlns:a="http://schemas.openxmlformats.org/drawingml/2006/main" id="77" idx="0"/>
@@ -9336,7 +9473,7 @@
           <a:prstGeom xmlns:a="http://schemas.openxmlformats.org/drawingml/2006/main" prst="straightConnector1">
             <a:avLst/>
           </a:prstGeom>
-          <a:ln xmlns:a="http://schemas.openxmlformats.org/drawingml/2006/main" w="19050" cap="rnd">
+          <a:ln xmlns:a="http://schemas.openxmlformats.org/drawingml/2006/main" w="16193" cap="rnd">
             <a:solidFill>
               <a:srgbClr val="1D2B36"/>
             </a:solidFill>
@@ -9349,7 +9486,7 @@
       </p:cxnSp>
       <p:cxnSp>
         <p:nvCxnSpPr>
-          <p:cNvPr id="2593" name="직선 화살표 연결선 855"/>
+          <p:cNvPr id="5873" name="직선 화살표 연결선 855"/>
           <p:cNvCxnSpPr>
             <a:stCxn xmlns:a="http://schemas.openxmlformats.org/drawingml/2006/main" id="77" idx="2"/>
             <a:endCxn xmlns:a="http://schemas.openxmlformats.org/drawingml/2006/main" id="82" idx="0"/>
@@ -9359,12 +9496,12 @@
         <p:spPr>
           <a:xfrm xmlns:a="http://schemas.openxmlformats.org/drawingml/2006/main">
             <a:off x="9763125" y="5143500"/>
-            <a:ext cx="0" cy="333375"/>
+            <a:ext cx="0" cy="285750"/>
           </a:xfrm>
           <a:prstGeom xmlns:a="http://schemas.openxmlformats.org/drawingml/2006/main" prst="straightConnector1">
             <a:avLst/>
           </a:prstGeom>
-          <a:ln xmlns:a="http://schemas.openxmlformats.org/drawingml/2006/main" w="14288" cap="rnd">
+          <a:ln xmlns:a="http://schemas.openxmlformats.org/drawingml/2006/main" w="16193" cap="rnd">
             <a:solidFill>
               <a:srgbClr val="6E97B6"/>
             </a:solidFill>
@@ -9609,7 +9746,7 @@
       </p:sp>
       <p:cxnSp>
         <p:nvCxnSpPr>
-          <p:cNvPr id="2602" name="직선 화살표 연결선 867"/>
+          <p:cNvPr id="5882" name="직선 화살표 연결선 867"/>
           <p:cNvCxnSpPr>
             <a:stCxn xmlns:a="http://schemas.openxmlformats.org/drawingml/2006/main" id="197" idx="3"/>
             <a:endCxn xmlns:a="http://schemas.openxmlformats.org/drawingml/2006/main" id="198" idx="1"/>
@@ -9624,7 +9761,7 @@
           <a:prstGeom xmlns:a="http://schemas.openxmlformats.org/drawingml/2006/main" prst="straightConnector1">
             <a:avLst/>
           </a:prstGeom>
-          <a:ln xmlns:a="http://schemas.openxmlformats.org/drawingml/2006/main" w="19050" cap="rnd">
+          <a:ln xmlns:a="http://schemas.openxmlformats.org/drawingml/2006/main" w="16193" cap="rnd">
             <a:solidFill>
               <a:srgbClr val="0F7040"/>
             </a:solidFill>
@@ -9637,7 +9774,7 @@
       </p:cxnSp>
       <p:cxnSp>
         <p:nvCxnSpPr>
-          <p:cNvPr id="2603" name="직선 화살표 연결선 868"/>
+          <p:cNvPr id="5883" name="직선 화살표 연결선 868"/>
           <p:cNvCxnSpPr>
             <a:stCxn xmlns:a="http://schemas.openxmlformats.org/drawingml/2006/main" id="198" idx="0"/>
           </p:cNvCxnSpPr>
@@ -9651,7 +9788,7 @@
           <a:prstGeom xmlns:a="http://schemas.openxmlformats.org/drawingml/2006/main" prst="straightConnector1">
             <a:avLst/>
           </a:prstGeom>
-          <a:ln xmlns:a="http://schemas.openxmlformats.org/drawingml/2006/main" w="19050" cap="rnd">
+          <a:ln xmlns:a="http://schemas.openxmlformats.org/drawingml/2006/main" w="16193" cap="rnd">
             <a:solidFill>
               <a:srgbClr val="0F7040"/>
             </a:solidFill>
@@ -9664,7 +9801,7 @@
       </p:cxnSp>
       <p:cxnSp>
         <p:nvCxnSpPr>
-          <p:cNvPr id="2604" name="직선 화살표 연결선 869"/>
+          <p:cNvPr id="5884" name="직선 화살표 연결선 869"/>
           <p:cNvCxnSpPr>
             <a:endCxn xmlns:a="http://schemas.openxmlformats.org/drawingml/2006/main" id="95" idx="1"/>
           </p:cNvCxnSpPr>
@@ -9678,7 +9815,7 @@
           <a:prstGeom xmlns:a="http://schemas.openxmlformats.org/drawingml/2006/main" prst="straightConnector1">
             <a:avLst/>
           </a:prstGeom>
-          <a:ln xmlns:a="http://schemas.openxmlformats.org/drawingml/2006/main" w="19050" cap="rnd">
+          <a:ln xmlns:a="http://schemas.openxmlformats.org/drawingml/2006/main" w="16193" cap="rnd">
             <a:solidFill>
               <a:srgbClr val="0F7040"/>
             </a:solidFill>
@@ -9691,7 +9828,7 @@
       </p:cxnSp>
       <p:cxnSp>
         <p:nvCxnSpPr>
-          <p:cNvPr id="2605" name="직선 화살표 연결선 870"/>
+          <p:cNvPr id="5885" name="직선 화살표 연결선 870"/>
           <p:cNvCxnSpPr>
             <a:stCxn xmlns:a="http://schemas.openxmlformats.org/drawingml/2006/main" id="95" idx="2"/>
             <a:endCxn xmlns:a="http://schemas.openxmlformats.org/drawingml/2006/main" id="123" idx="0"/>
@@ -9706,7 +9843,7 @@
           <a:prstGeom xmlns:a="http://schemas.openxmlformats.org/drawingml/2006/main" prst="straightConnector1">
             <a:avLst/>
           </a:prstGeom>
-          <a:ln xmlns:a="http://schemas.openxmlformats.org/drawingml/2006/main" w="20955" cap="rnd">
+          <a:ln xmlns:a="http://schemas.openxmlformats.org/drawingml/2006/main" w="16193" cap="rnd">
             <a:solidFill>
               <a:srgbClr val="0F7040"/>
             </a:solidFill>
@@ -9719,7 +9856,7 @@
       </p:cxnSp>
       <p:cxnSp>
         <p:nvCxnSpPr>
-          <p:cNvPr id="2606" name="연결선: 꺾임 872"/>
+          <p:cNvPr id="5886" name="연결선: 꺾임 872"/>
           <p:cNvCxnSpPr>
             <a:stCxn xmlns:a="http://schemas.openxmlformats.org/drawingml/2006/main" id="211" idx="2"/>
             <a:endCxn xmlns:a="http://schemas.openxmlformats.org/drawingml/2006/main" id="128" idx="0"/>
@@ -9736,7 +9873,7 @@
               <a:gd name="adj1" fmla="val 50000"/>
             </a:avLst>
           </a:prstGeom>
-          <a:ln xmlns:a="http://schemas.openxmlformats.org/drawingml/2006/main" w="15240" cap="rnd">
+          <a:ln xmlns:a="http://schemas.openxmlformats.org/drawingml/2006/main" w="16193" cap="rnd">
             <a:solidFill>
               <a:srgbClr val="0F7040"/>
             </a:solidFill>
@@ -9749,7 +9886,7 @@
       </p:cxnSp>
       <p:cxnSp>
         <p:nvCxnSpPr>
-          <p:cNvPr id="2607" name="직선 화살표 연결선 871"/>
+          <p:cNvPr id="5887" name="직선 화살표 연결선 871"/>
           <p:cNvCxnSpPr>
             <a:stCxn xmlns:a="http://schemas.openxmlformats.org/drawingml/2006/main" id="123" idx="2"/>
             <a:endCxn xmlns:a="http://schemas.openxmlformats.org/drawingml/2006/main" id="125" idx="0"/>
@@ -9764,7 +9901,7 @@
           <a:prstGeom xmlns:a="http://schemas.openxmlformats.org/drawingml/2006/main" prst="straightConnector1">
             <a:avLst/>
           </a:prstGeom>
-          <a:ln xmlns:a="http://schemas.openxmlformats.org/drawingml/2006/main" w="20955" cap="rnd">
+          <a:ln xmlns:a="http://schemas.openxmlformats.org/drawingml/2006/main" w="16193" cap="rnd">
             <a:solidFill>
               <a:srgbClr val="0F7040"/>
             </a:solidFill>
@@ -9777,7 +9914,7 @@
       </p:cxnSp>
       <p:cxnSp>
         <p:nvCxnSpPr>
-          <p:cNvPr id="2608" name="연결선: 꺾임 874"/>
+          <p:cNvPr id="5888" name="연결선: 꺾임 874"/>
           <p:cNvCxnSpPr>
             <a:stCxn xmlns:a="http://schemas.openxmlformats.org/drawingml/2006/main" id="128" idx="2"/>
             <a:endCxn xmlns:a="http://schemas.openxmlformats.org/drawingml/2006/main" id="134" idx="0"/>
@@ -9792,10 +9929,10 @@
           <a:prstGeom xmlns:a="http://schemas.openxmlformats.org/drawingml/2006/main" prst="bentConnector4">
             <a:avLst>
               <a:gd name="adj1" fmla="val 0"/>
-              <a:gd name="adj2" fmla="val 39583"/>
+              <a:gd name="adj2" fmla="val 75000"/>
             </a:avLst>
           </a:prstGeom>
-          <a:ln xmlns:a="http://schemas.openxmlformats.org/drawingml/2006/main" w="14288" cap="rnd">
+          <a:ln xmlns:a="http://schemas.openxmlformats.org/drawingml/2006/main" w="16193" cap="rnd">
             <a:solidFill>
               <a:srgbClr val="1769B0"/>
             </a:solidFill>
@@ -9808,7 +9945,7 @@
       </p:cxnSp>
       <p:cxnSp>
         <p:nvCxnSpPr>
-          <p:cNvPr id="2609" name="직선 화살표 연결선 875"/>
+          <p:cNvPr id="5889" name="직선 화살표 연결선 875"/>
           <p:cNvCxnSpPr>
             <a:stCxn xmlns:a="http://schemas.openxmlformats.org/drawingml/2006/main" id="130" idx="2"/>
             <a:endCxn xmlns:a="http://schemas.openxmlformats.org/drawingml/2006/main" id="134" idx="0"/>
@@ -9823,7 +9960,7 @@
           <a:prstGeom xmlns:a="http://schemas.openxmlformats.org/drawingml/2006/main" prst="straightConnector1">
             <a:avLst/>
           </a:prstGeom>
-          <a:ln xmlns:a="http://schemas.openxmlformats.org/drawingml/2006/main" w="14288" cap="rnd">
+          <a:ln xmlns:a="http://schemas.openxmlformats.org/drawingml/2006/main" w="16193" cap="rnd">
             <a:solidFill>
               <a:srgbClr val="1769B0"/>
             </a:solidFill>
@@ -9836,7 +9973,7 @@
       </p:cxnSp>
       <p:cxnSp>
         <p:nvCxnSpPr>
-          <p:cNvPr id="2610" name="연결선: 꺾임 876"/>
+          <p:cNvPr id="5890" name="연결선: 꺾임 876"/>
           <p:cNvCxnSpPr>
             <a:stCxn xmlns:a="http://schemas.openxmlformats.org/drawingml/2006/main" id="132" idx="2"/>
             <a:endCxn xmlns:a="http://schemas.openxmlformats.org/drawingml/2006/main" id="134" idx="0"/>
@@ -9851,10 +9988,10 @@
           <a:prstGeom xmlns:a="http://schemas.openxmlformats.org/drawingml/2006/main" prst="bentConnector4">
             <a:avLst>
               <a:gd name="adj1" fmla="val 0"/>
-              <a:gd name="adj2" fmla="val 39583"/>
+              <a:gd name="adj2" fmla="val 75000"/>
             </a:avLst>
           </a:prstGeom>
-          <a:ln xmlns:a="http://schemas.openxmlformats.org/drawingml/2006/main" w="14288" cap="rnd">
+          <a:ln xmlns:a="http://schemas.openxmlformats.org/drawingml/2006/main" w="16193" cap="rnd">
             <a:solidFill>
               <a:srgbClr val="1769B0"/>
             </a:solidFill>
@@ -9867,7 +10004,7 @@
       </p:cxnSp>
       <p:cxnSp>
         <p:nvCxnSpPr>
-          <p:cNvPr id="2611" name="연결선: 꺾임 877"/>
+          <p:cNvPr id="5891" name="연결선: 꺾임 877"/>
           <p:cNvCxnSpPr>
             <a:stCxn xmlns:a="http://schemas.openxmlformats.org/drawingml/2006/main" id="134" idx="2"/>
             <a:endCxn xmlns:a="http://schemas.openxmlformats.org/drawingml/2006/main" id="139" idx="0"/>
@@ -9885,7 +10022,7 @@
               <a:gd name="adj2" fmla="val 50000"/>
             </a:avLst>
           </a:prstGeom>
-          <a:ln xmlns:a="http://schemas.openxmlformats.org/drawingml/2006/main" w="14288" cap="rnd">
+          <a:ln xmlns:a="http://schemas.openxmlformats.org/drawingml/2006/main" w="16193" cap="rnd">
             <a:solidFill>
               <a:srgbClr val="1769B0"/>
             </a:solidFill>
@@ -9898,7 +10035,7 @@
       </p:cxnSp>
       <p:cxnSp>
         <p:nvCxnSpPr>
-          <p:cNvPr id="2612" name="직선 화살표 연결선 878"/>
+          <p:cNvPr id="5892" name="직선 화살표 연결선 878"/>
           <p:cNvCxnSpPr>
             <a:stCxn xmlns:a="http://schemas.openxmlformats.org/drawingml/2006/main" id="134" idx="2"/>
             <a:endCxn xmlns:a="http://schemas.openxmlformats.org/drawingml/2006/main" id="142" idx="0"/>
@@ -9913,7 +10050,7 @@
           <a:prstGeom xmlns:a="http://schemas.openxmlformats.org/drawingml/2006/main" prst="straightConnector1">
             <a:avLst/>
           </a:prstGeom>
-          <a:ln xmlns:a="http://schemas.openxmlformats.org/drawingml/2006/main" w="14288" cap="rnd">
+          <a:ln xmlns:a="http://schemas.openxmlformats.org/drawingml/2006/main" w="16193" cap="rnd">
             <a:solidFill>
               <a:srgbClr val="1769B0"/>
             </a:solidFill>
@@ -9926,7 +10063,7 @@
       </p:cxnSp>
       <p:cxnSp>
         <p:nvCxnSpPr>
-          <p:cNvPr id="2613" name="연결선: 꺾임 879"/>
+          <p:cNvPr id="5893" name="연결선: 꺾임 879"/>
           <p:cNvCxnSpPr>
             <a:stCxn xmlns:a="http://schemas.openxmlformats.org/drawingml/2006/main" id="134" idx="2"/>
             <a:endCxn xmlns:a="http://schemas.openxmlformats.org/drawingml/2006/main" id="145" idx="0"/>
@@ -9944,7 +10081,7 @@
               <a:gd name="adj2" fmla="val 50000"/>
             </a:avLst>
           </a:prstGeom>
-          <a:ln xmlns:a="http://schemas.openxmlformats.org/drawingml/2006/main" w="14288" cap="rnd">
+          <a:ln xmlns:a="http://schemas.openxmlformats.org/drawingml/2006/main" w="16193" cap="rnd">
             <a:solidFill>
               <a:srgbClr val="1769B0"/>
             </a:solidFill>
@@ -9957,7 +10094,7 @@
       </p:cxnSp>
       <p:cxnSp>
         <p:nvCxnSpPr>
-          <p:cNvPr id="2614" name="직선 화살표 연결선 880"/>
+          <p:cNvPr id="5894" name="직선 화살표 연결선 880"/>
           <p:cNvCxnSpPr>
             <a:stCxn xmlns:a="http://schemas.openxmlformats.org/drawingml/2006/main" id="139" idx="2"/>
             <a:endCxn xmlns:a="http://schemas.openxmlformats.org/drawingml/2006/main" id="148" idx="0"/>
@@ -9972,7 +10109,7 @@
           <a:prstGeom xmlns:a="http://schemas.openxmlformats.org/drawingml/2006/main" prst="straightConnector1">
             <a:avLst/>
           </a:prstGeom>
-          <a:ln xmlns:a="http://schemas.openxmlformats.org/drawingml/2006/main" w="14288" cap="rnd">
+          <a:ln xmlns:a="http://schemas.openxmlformats.org/drawingml/2006/main" w="16193" cap="rnd">
             <a:solidFill>
               <a:srgbClr val="D06D13"/>
             </a:solidFill>
@@ -9985,7 +10122,7 @@
       </p:cxnSp>
       <p:cxnSp>
         <p:nvCxnSpPr>
-          <p:cNvPr id="2615" name="직선 화살표 연결선 881"/>
+          <p:cNvPr id="5895" name="직선 화살표 연결선 881"/>
           <p:cNvCxnSpPr>
             <a:stCxn xmlns:a="http://schemas.openxmlformats.org/drawingml/2006/main" id="142" idx="2"/>
             <a:endCxn xmlns:a="http://schemas.openxmlformats.org/drawingml/2006/main" id="150" idx="0"/>
@@ -10000,7 +10137,7 @@
           <a:prstGeom xmlns:a="http://schemas.openxmlformats.org/drawingml/2006/main" prst="straightConnector1">
             <a:avLst/>
           </a:prstGeom>
-          <a:ln xmlns:a="http://schemas.openxmlformats.org/drawingml/2006/main" w="14288" cap="rnd">
+          <a:ln xmlns:a="http://schemas.openxmlformats.org/drawingml/2006/main" w="16193" cap="rnd">
             <a:solidFill>
               <a:srgbClr val="0F7040"/>
             </a:solidFill>
@@ -10013,7 +10150,7 @@
       </p:cxnSp>
       <p:cxnSp>
         <p:nvCxnSpPr>
-          <p:cNvPr id="2616" name="직선 화살표 연결선 882"/>
+          <p:cNvPr id="5896" name="직선 화살표 연결선 882"/>
           <p:cNvCxnSpPr>
             <a:stCxn xmlns:a="http://schemas.openxmlformats.org/drawingml/2006/main" id="145" idx="2"/>
             <a:endCxn xmlns:a="http://schemas.openxmlformats.org/drawingml/2006/main" id="152" idx="0"/>
@@ -10028,7 +10165,7 @@
           <a:prstGeom xmlns:a="http://schemas.openxmlformats.org/drawingml/2006/main" prst="straightConnector1">
             <a:avLst/>
           </a:prstGeom>
-          <a:ln xmlns:a="http://schemas.openxmlformats.org/drawingml/2006/main" w="14288" cap="rnd">
+          <a:ln xmlns:a="http://schemas.openxmlformats.org/drawingml/2006/main" w="16193" cap="rnd">
             <a:solidFill>
               <a:srgbClr val="167D7D"/>
             </a:solidFill>
@@ -10041,7 +10178,7 @@
       </p:cxnSp>
       <p:cxnSp>
         <p:nvCxnSpPr>
-          <p:cNvPr id="2617" name="연결선: 꺾임 883"/>
+          <p:cNvPr id="5897" name="연결선: 꺾임 883"/>
           <p:cNvCxnSpPr>
             <a:stCxn xmlns:a="http://schemas.openxmlformats.org/drawingml/2006/main" id="148" idx="2"/>
             <a:endCxn xmlns:a="http://schemas.openxmlformats.org/drawingml/2006/main" id="154" idx="0"/>
@@ -10058,7 +10195,7 @@
               <a:gd name="adj1" fmla="val 50000"/>
             </a:avLst>
           </a:prstGeom>
-          <a:ln xmlns:a="http://schemas.openxmlformats.org/drawingml/2006/main" w="12383" cap="rnd">
+          <a:ln xmlns:a="http://schemas.openxmlformats.org/drawingml/2006/main" w="16193" cap="rnd">
             <a:solidFill>
               <a:srgbClr val="87949D"/>
             </a:solidFill>
@@ -10158,92 +10295,7 @@
       </p:sp>
       <p:cxnSp>
         <p:nvCxnSpPr>
-          <p:cNvPr id="2621" name="연결선: 꺾임 161"/>
-          <p:cNvCxnSpPr>
-            <a:stCxn xmlns:a="http://schemas.openxmlformats.org/drawingml/2006/main" id="21" idx="2"/>
-            <a:endCxn xmlns:a="http://schemas.openxmlformats.org/drawingml/2006/main" id="62" idx="1"/>
-          </p:cNvCxnSpPr>
-          <p:nvPr/>
-        </p:nvCxnSpPr>
-        <p:spPr>
-          <a:xfrm xmlns:a="http://schemas.openxmlformats.org/drawingml/2006/main" rot="5400000" flipH="1" flipV="1">
-            <a:off x="1900237" y="1042987"/>
-            <a:ext cx="5676900" cy="6334125"/>
-          </a:xfrm>
-          <a:prstGeom xmlns:a="http://schemas.openxmlformats.org/drawingml/2006/main" prst="bentConnector4">
-            <a:avLst>
-              <a:gd name="adj1" fmla="val -23314"/>
-              <a:gd name="adj2" fmla="val 96050"/>
-            </a:avLst>
-          </a:prstGeom>
-          <a:ln xmlns:a="http://schemas.openxmlformats.org/drawingml/2006/main" w="19050">
-            <a:solidFill>
-              <a:srgbClr val="1D2B36"/>
-            </a:solidFill>
-            <a:headEnd type="none" w="med" len="med"/>
-            <a:tailEnd type="arrow" w="med" len="med"/>
-          </a:ln>
-        </p:spPr>
-        <p:style>
-          <a:lnRef xmlns:a="http://schemas.openxmlformats.org/drawingml/2006/main" idx="1">
-            <a:schemeClr val="dk1"/>
-          </a:lnRef>
-          <a:fillRef xmlns:a="http://schemas.openxmlformats.org/drawingml/2006/main" idx="0">
-            <a:schemeClr val="dk1"/>
-          </a:fillRef>
-          <a:effectRef xmlns:a="http://schemas.openxmlformats.org/drawingml/2006/main" idx="0">
-            <a:schemeClr val="dk1"/>
-          </a:effectRef>
-          <a:fontRef xmlns:a="http://schemas.openxmlformats.org/drawingml/2006/main" idx="minor">
-            <a:schemeClr val="tx1"/>
-          </a:fontRef>
-        </p:style>
-      </p:cxnSp>
-      <p:cxnSp>
-        <p:nvCxnSpPr>
-          <p:cNvPr id="2622" name="연결선: 꺾임 175"/>
-          <p:cNvCxnSpPr>
-            <a:stCxn xmlns:a="http://schemas.openxmlformats.org/drawingml/2006/main" id="43" idx="3"/>
-            <a:endCxn xmlns:a="http://schemas.openxmlformats.org/drawingml/2006/main" id="171" idx="1"/>
-          </p:cNvCxnSpPr>
-          <p:nvPr/>
-        </p:nvCxnSpPr>
-        <p:spPr>
-          <a:xfrm xmlns:a="http://schemas.openxmlformats.org/drawingml/2006/main" flipV="1">
-            <a:off x="5762625" y="1114425"/>
-            <a:ext cx="2152650" cy="6048375"/>
-          </a:xfrm>
-          <a:prstGeom xmlns:a="http://schemas.openxmlformats.org/drawingml/2006/main" prst="bentConnector3">
-            <a:avLst>
-              <a:gd name="adj1" fmla="val 76549"/>
-            </a:avLst>
-          </a:prstGeom>
-          <a:ln xmlns:a="http://schemas.openxmlformats.org/drawingml/2006/main" w="19050">
-            <a:solidFill>
-              <a:srgbClr val="1D2B36"/>
-            </a:solidFill>
-            <a:headEnd type="none" w="med" len="med"/>
-            <a:tailEnd type="arrow" w="med" len="med"/>
-          </a:ln>
-        </p:spPr>
-        <p:style>
-          <a:lnRef xmlns:a="http://schemas.openxmlformats.org/drawingml/2006/main" idx="1">
-            <a:schemeClr val="dk1"/>
-          </a:lnRef>
-          <a:fillRef xmlns:a="http://schemas.openxmlformats.org/drawingml/2006/main" idx="0">
-            <a:schemeClr val="dk1"/>
-          </a:fillRef>
-          <a:effectRef xmlns:a="http://schemas.openxmlformats.org/drawingml/2006/main" idx="0">
-            <a:schemeClr val="dk1"/>
-          </a:effectRef>
-          <a:fontRef xmlns:a="http://schemas.openxmlformats.org/drawingml/2006/main" idx="minor">
-            <a:schemeClr val="tx1"/>
-          </a:fontRef>
-        </p:style>
-      </p:cxnSp>
-      <p:cxnSp>
-        <p:nvCxnSpPr>
-          <p:cNvPr id="2623" name="직선 화살표 연결선 184"/>
+          <p:cNvPr id="5901" name="직선 화살표 연결선 184"/>
           <p:cNvCxnSpPr>
             <a:stCxn xmlns:a="http://schemas.openxmlformats.org/drawingml/2006/main" id="51" idx="2"/>
             <a:endCxn xmlns:a="http://schemas.openxmlformats.org/drawingml/2006/main" id="53" idx="0"/>
@@ -10252,13 +10304,13 @@
         </p:nvCxnSpPr>
         <p:spPr>
           <a:xfrm xmlns:a="http://schemas.openxmlformats.org/drawingml/2006/main">
-            <a:off x="6474620" y="2766559"/>
-            <a:ext cx="0" cy="386216"/>
+            <a:off x="6474619" y="2771775"/>
+            <a:ext cx="0" cy="381000"/>
           </a:xfrm>
           <a:prstGeom xmlns:a="http://schemas.openxmlformats.org/drawingml/2006/main" prst="straightConnector1">
             <a:avLst/>
           </a:prstGeom>
-          <a:ln xmlns:a="http://schemas.openxmlformats.org/drawingml/2006/main" w="19050" cap="rnd">
+          <a:ln xmlns:a="http://schemas.openxmlformats.org/drawingml/2006/main" w="16193" cap="rnd">
             <a:solidFill>
               <a:srgbClr val="1D2B36"/>
             </a:solidFill>
@@ -10271,7 +10323,7 @@
       </p:cxnSp>
       <p:cxnSp>
         <p:nvCxnSpPr>
-          <p:cNvPr id="2624" name="직선 화살표 연결선 188"/>
+          <p:cNvPr id="5902" name="직선 화살표 연결선 188"/>
           <p:cNvCxnSpPr>
             <a:stCxn xmlns:a="http://schemas.openxmlformats.org/drawingml/2006/main" id="53" idx="2"/>
             <a:endCxn xmlns:a="http://schemas.openxmlformats.org/drawingml/2006/main" id="55" idx="0"/>
@@ -10280,13 +10332,13 @@
         </p:nvCxnSpPr>
         <p:spPr>
           <a:xfrm xmlns:a="http://schemas.openxmlformats.org/drawingml/2006/main">
-            <a:off x="6474620" y="3792084"/>
-            <a:ext cx="4762" cy="313191"/>
+            <a:off x="6474619" y="3762375"/>
+            <a:ext cx="4763" cy="342900"/>
           </a:xfrm>
           <a:prstGeom xmlns:a="http://schemas.openxmlformats.org/drawingml/2006/main" prst="straightConnector1">
             <a:avLst/>
           </a:prstGeom>
-          <a:ln xmlns:a="http://schemas.openxmlformats.org/drawingml/2006/main" w="19050" cap="rnd">
+          <a:ln xmlns:a="http://schemas.openxmlformats.org/drawingml/2006/main" w="16193" cap="rnd">
             <a:solidFill>
               <a:srgbClr val="1D2B36"/>
             </a:solidFill>
@@ -10299,7 +10351,7 @@
       </p:cxnSp>
       <p:cxnSp>
         <p:nvCxnSpPr>
-          <p:cNvPr id="2625" name="직선 화살표 연결선 200"/>
+          <p:cNvPr id="5903" name="직선 화살표 연결선 200"/>
           <p:cNvCxnSpPr>
             <a:stCxn xmlns:a="http://schemas.openxmlformats.org/drawingml/2006/main" id="55" idx="2"/>
             <a:endCxn xmlns:a="http://schemas.openxmlformats.org/drawingml/2006/main" id="57" idx="0"/>
@@ -10308,13 +10360,13 @@
         </p:nvCxnSpPr>
         <p:spPr>
           <a:xfrm xmlns:a="http://schemas.openxmlformats.org/drawingml/2006/main" flipH="1">
-            <a:off x="6474619" y="4772025"/>
-            <a:ext cx="4763" cy="123825"/>
+            <a:off x="6474619" y="4752975"/>
+            <a:ext cx="4763" cy="142875"/>
           </a:xfrm>
           <a:prstGeom xmlns:a="http://schemas.openxmlformats.org/drawingml/2006/main" prst="straightConnector1">
             <a:avLst/>
           </a:prstGeom>
-          <a:ln xmlns:a="http://schemas.openxmlformats.org/drawingml/2006/main" w="19050" cap="rnd">
+          <a:ln xmlns:a="http://schemas.openxmlformats.org/drawingml/2006/main" w="16193" cap="rnd">
             <a:solidFill>
               <a:srgbClr val="1D2B36"/>
             </a:solidFill>
@@ -10327,7 +10379,7 @@
       </p:cxnSp>
       <p:cxnSp>
         <p:nvCxnSpPr>
-          <p:cNvPr id="2626" name="연결선: 꺾임 227"/>
+          <p:cNvPr id="5904" name="연결선: 꺾임 227"/>
           <p:cNvCxnSpPr/>
           <p:nvPr/>
         </p:nvCxnSpPr>
@@ -10339,7 +10391,7 @@
           <a:prstGeom xmlns:a="http://schemas.openxmlformats.org/drawingml/2006/main" prst="bentConnector2">
             <a:avLst/>
           </a:prstGeom>
-          <a:ln xmlns:a="http://schemas.openxmlformats.org/drawingml/2006/main" w="15240" cap="rnd">
+          <a:ln xmlns:a="http://schemas.openxmlformats.org/drawingml/2006/main" w="16193" cap="rnd">
             <a:solidFill>
               <a:srgbClr val="0F7040"/>
             </a:solidFill>
@@ -10352,7 +10404,7 @@
       </p:cxnSp>
       <p:cxnSp>
         <p:nvCxnSpPr>
-          <p:cNvPr id="2627" name="직선 화살표 연결선 241"/>
+          <p:cNvPr id="5905" name="직선 화살표 연결선 241"/>
           <p:cNvCxnSpPr>
             <a:stCxn xmlns:a="http://schemas.openxmlformats.org/drawingml/2006/main" id="152" idx="2"/>
             <a:endCxn xmlns:a="http://schemas.openxmlformats.org/drawingml/2006/main" id="248" idx="0"/>
@@ -10367,7 +10419,7 @@
           <a:prstGeom xmlns:a="http://schemas.openxmlformats.org/drawingml/2006/main" prst="straightConnector1">
             <a:avLst/>
           </a:prstGeom>
-          <a:ln xmlns:a="http://schemas.openxmlformats.org/drawingml/2006/main" w="14288" cap="rnd">
+          <a:ln xmlns:a="http://schemas.openxmlformats.org/drawingml/2006/main" w="16193" cap="rnd">
             <a:solidFill>
               <a:srgbClr val="167D7D"/>
             </a:solidFill>
@@ -10380,7 +10432,7 @@
       </p:cxnSp>
       <p:cxnSp>
         <p:nvCxnSpPr>
-          <p:cNvPr id="2628" name="직선 화살표 연결선 253"/>
+          <p:cNvPr id="5906" name="직선 화살표 연결선 253"/>
           <p:cNvCxnSpPr>
             <a:stCxn xmlns:a="http://schemas.openxmlformats.org/drawingml/2006/main" id="150" idx="2"/>
             <a:endCxn xmlns:a="http://schemas.openxmlformats.org/drawingml/2006/main" id="769" idx="0"/>
@@ -10395,7 +10447,7 @@
           <a:prstGeom xmlns:a="http://schemas.openxmlformats.org/drawingml/2006/main" prst="straightConnector1">
             <a:avLst/>
           </a:prstGeom>
-          <a:ln xmlns:a="http://schemas.openxmlformats.org/drawingml/2006/main" w="14288" cap="rnd">
+          <a:ln xmlns:a="http://schemas.openxmlformats.org/drawingml/2006/main" w="16193" cap="rnd">
             <a:solidFill>
               <a:srgbClr val="0F7040"/>
             </a:solidFill>
@@ -10408,14 +10460,14 @@
       </p:cxnSp>
       <p:pic>
         <p:nvPicPr>
-          <p:cNvPr id="2629" name="그림 162"/>
+          <p:cNvPr id="5907" name="그림 162"/>
           <p:cNvPicPr>
             <a:picLocks xmlns:a="http://schemas.openxmlformats.org/drawingml/2006/main" noChangeAspect="1"/>
           </p:cNvPicPr>
           <p:nvPr/>
         </p:nvPicPr>
         <p:blipFill>
-          <a:blip xmlns:r="http://schemas.openxmlformats.org/officeDocument/2006/relationships" xmlns:a="http://schemas.openxmlformats.org/drawingml/2006/main" r:embed="R84d1b27dee104d01">
+          <a:blip xmlns:r="http://schemas.openxmlformats.org/officeDocument/2006/relationships" xmlns:a="http://schemas.openxmlformats.org/drawingml/2006/main" r:embed="Rff6bfb68e8d44fc1">
             <a:biLevel thresh="75000"/>
           </a:blip>
           <a:stretch xmlns:a="http://schemas.openxmlformats.org/drawingml/2006/main">
@@ -10434,14 +10486,14 @@
       </p:pic>
       <p:pic>
         <p:nvPicPr>
-          <p:cNvPr id="2630" name="그림 169"/>
+          <p:cNvPr id="5908" name="그림 169"/>
           <p:cNvPicPr>
             <a:picLocks xmlns:a="http://schemas.openxmlformats.org/drawingml/2006/main" noChangeAspect="1"/>
           </p:cNvPicPr>
           <p:nvPr/>
         </p:nvPicPr>
         <p:blipFill>
-          <a:blip xmlns:r="http://schemas.openxmlformats.org/officeDocument/2006/relationships" xmlns:a="http://schemas.openxmlformats.org/drawingml/2006/main" r:embed="R2344dca673904531">
+          <a:blip xmlns:r="http://schemas.openxmlformats.org/officeDocument/2006/relationships" xmlns:a="http://schemas.openxmlformats.org/drawingml/2006/main" r:embed="Rf2c901423a1c4f95">
             <a:duotone>
               <a:schemeClr val="accent4">
                 <a:shade val="45000"/>
@@ -10466,7 +10518,7 @@
       </p:pic>
       <p:cxnSp>
         <p:nvCxnSpPr>
-          <p:cNvPr id="2631" name="직선 화살표 연결선 187"/>
+          <p:cNvPr id="5909" name="직선 화살표 연결선 187"/>
           <p:cNvCxnSpPr>
             <a:stCxn xmlns:a="http://schemas.openxmlformats.org/drawingml/2006/main" id="33" idx="3"/>
             <a:endCxn xmlns:a="http://schemas.openxmlformats.org/drawingml/2006/main" id="51" idx="1"/>
@@ -10476,12 +10528,12 @@
         <p:spPr>
           <a:xfrm xmlns:a="http://schemas.openxmlformats.org/drawingml/2006/main">
             <a:off x="5762625" y="2466975"/>
-            <a:ext cx="230982" cy="4309"/>
+            <a:ext cx="230981" cy="0"/>
           </a:xfrm>
           <a:prstGeom xmlns:a="http://schemas.openxmlformats.org/drawingml/2006/main" prst="straightConnector1">
             <a:avLst/>
           </a:prstGeom>
-          <a:ln xmlns:a="http://schemas.openxmlformats.org/drawingml/2006/main" w="19050" cap="rnd">
+          <a:ln xmlns:a="http://schemas.openxmlformats.org/drawingml/2006/main" w="16193" cap="rnd">
             <a:solidFill>
               <a:srgbClr val="1D2B36"/>
             </a:solidFill>
@@ -10491,48 +10543,6 @@
             <a:tailEnd type="arrow" w="sm" len="sm"/>
           </a:ln>
         </p:spPr>
-      </p:cxnSp>
-      <p:cxnSp>
-        <p:nvCxnSpPr>
-          <p:cNvPr id="2632" name="연결선: 꺾임 212"/>
-          <p:cNvCxnSpPr>
-            <a:stCxn xmlns:a="http://schemas.openxmlformats.org/drawingml/2006/main" id="77" idx="3"/>
-            <a:endCxn xmlns:a="http://schemas.openxmlformats.org/drawingml/2006/main" id="92" idx="3"/>
-          </p:cNvCxnSpPr>
-          <p:nvPr/>
-        </p:nvCxnSpPr>
-        <p:spPr>
-          <a:xfrm xmlns:a="http://schemas.openxmlformats.org/drawingml/2006/main">
-            <a:off x="11620500" y="4619625"/>
-            <a:ext cx="12700" cy="3057525"/>
-          </a:xfrm>
-          <a:prstGeom xmlns:a="http://schemas.openxmlformats.org/drawingml/2006/main" prst="bentConnector3">
-            <a:avLst>
-              <a:gd name="adj1" fmla="val 1800000"/>
-            </a:avLst>
-          </a:prstGeom>
-          <a:ln xmlns:a="http://schemas.openxmlformats.org/drawingml/2006/main" w="19050">
-            <a:solidFill>
-              <a:srgbClr val="0F7040"/>
-            </a:solidFill>
-            <a:headEnd type="none" w="med" len="med"/>
-            <a:tailEnd type="arrow" w="med" len="med"/>
-          </a:ln>
-        </p:spPr>
-        <p:style>
-          <a:lnRef xmlns:a="http://schemas.openxmlformats.org/drawingml/2006/main" idx="1">
-            <a:schemeClr val="dk1"/>
-          </a:lnRef>
-          <a:fillRef xmlns:a="http://schemas.openxmlformats.org/drawingml/2006/main" idx="0">
-            <a:schemeClr val="dk1"/>
-          </a:fillRef>
-          <a:effectRef xmlns:a="http://schemas.openxmlformats.org/drawingml/2006/main" idx="0">
-            <a:schemeClr val="dk1"/>
-          </a:effectRef>
-          <a:fontRef xmlns:a="http://schemas.openxmlformats.org/drawingml/2006/main" idx="minor">
-            <a:schemeClr val="tx1"/>
-          </a:fontRef>
-        </p:style>
       </p:cxnSp>
       <p:sp>
         <p:nvSpPr>
@@ -11063,7 +11073,7 @@
       </p:sp>
       <p:cxnSp>
         <p:nvCxnSpPr>
-          <p:cNvPr id="2643" name="직선 화살표 연결선 769"/>
+          <p:cNvPr id="5920" name="직선 화살표 연결선 769"/>
           <p:cNvCxnSpPr>
             <a:stCxn xmlns:a="http://schemas.openxmlformats.org/drawingml/2006/main" id="154" idx="3"/>
             <a:endCxn xmlns:a="http://schemas.openxmlformats.org/drawingml/2006/main" id="236" idx="1"/>
@@ -11078,7 +11088,7 @@
           <a:prstGeom xmlns:a="http://schemas.openxmlformats.org/drawingml/2006/main" prst="straightConnector1">
             <a:avLst/>
           </a:prstGeom>
-          <a:ln xmlns:a="http://schemas.openxmlformats.org/drawingml/2006/main" w="14288" cap="rnd">
+          <a:ln xmlns:a="http://schemas.openxmlformats.org/drawingml/2006/main" w="16193" cap="rnd">
             <a:solidFill>
               <a:srgbClr val="87949D"/>
             </a:solidFill>
@@ -11089,6 +11099,222 @@
           </a:ln>
         </p:spPr>
       </p:cxnSp>
+      <p:sp>
+        <p:nvSpPr>
+          <p:cNvPr id="5705" name="index-to-search-routed-arrow">
+            <a:extLst xmlns:a="http://schemas.openxmlformats.org/drawingml/2006/main">
+              <a:ext uri="{FF2B5EF4-FFF2-40B4-BE49-F238E27FC236}">
+                <a16:creationId xmlns:a16="http://schemas.microsoft.com/office/drawing/2014/main" id="{A8D5F53B-1B91-4378-9F32-A94B49DA9AB1}"/>
+              </a:ext>
+            </a:extLst>
+          </p:cNvPr>
+          <p:cNvSpPr>
+            <a:spLocks xmlns:a="http://schemas.openxmlformats.org/drawingml/2006/main" noGrp="1"/>
+          </p:cNvSpPr>
+          <p:nvPr/>
+        </p:nvSpPr>
+        <p:spPr>
+          <a:xfrm xmlns:a="http://schemas.openxmlformats.org/drawingml/2006/main">
+            <a:off x="5762625" y="1038225"/>
+            <a:ext cx="2133600" cy="6096000"/>
+          </a:xfrm>
+          <a:custGeom xmlns:a="http://schemas.openxmlformats.org/drawingml/2006/main">
+            <a:pathLst>
+              <a:path w="2133600" h="6096000">
+                <a:moveTo>
+                  <a:pt x="0" y="6088856"/>
+                </a:moveTo>
+                <a:lnTo>
+                  <a:pt x="1897856" y="6088856"/>
+                </a:lnTo>
+                <a:lnTo>
+                  <a:pt x="1897856" y="59531"/>
+                </a:lnTo>
+                <a:lnTo>
+                  <a:pt x="2076450" y="59531"/>
+                </a:lnTo>
+                <a:lnTo>
+                  <a:pt x="2076450" y="28575"/>
+                </a:lnTo>
+                <a:lnTo>
+                  <a:pt x="2133600" y="66675"/>
+                </a:lnTo>
+                <a:lnTo>
+                  <a:pt x="2076450" y="104775"/>
+                </a:lnTo>
+                <a:lnTo>
+                  <a:pt x="2076450" y="73819"/>
+                </a:lnTo>
+                <a:lnTo>
+                  <a:pt x="1912144" y="73819"/>
+                </a:lnTo>
+                <a:lnTo>
+                  <a:pt x="1912144" y="6103144"/>
+                </a:lnTo>
+                <a:lnTo>
+                  <a:pt x="0" y="6103144"/>
+                </a:lnTo>
+                <a:close/>
+              </a:path>
+            </a:pathLst>
+          </a:custGeom>
+          <a:solidFill xmlns:a="http://schemas.openxmlformats.org/drawingml/2006/main">
+            <a:srgbClr val="1D2B36"/>
+          </a:solidFill>
+          <a:ln xmlns:a="http://schemas.openxmlformats.org/drawingml/2006/main" w="0">
+            <a:solidFill>
+              <a:srgbClr val="1D2B36"/>
+            </a:solidFill>
+            <a:prstDash val="solid"/>
+          </a:ln>
+        </p:spPr>
+      </p:sp>
+      <p:sp>
+        <p:nvSpPr>
+          <p:cNvPr id="5706" name="probe-to-search-routed-arrow">
+            <a:extLst xmlns:a="http://schemas.openxmlformats.org/drawingml/2006/main">
+              <a:ext uri="{FF2B5EF4-FFF2-40B4-BE49-F238E27FC236}">
+                <a16:creationId xmlns:a16="http://schemas.microsoft.com/office/drawing/2014/main" id="{5C6C3B7F-8AE4-42A9-A295-12291DFCD8AF}"/>
+              </a:ext>
+            </a:extLst>
+          </p:cNvPr>
+          <p:cNvSpPr>
+            <a:spLocks xmlns:a="http://schemas.openxmlformats.org/drawingml/2006/main" noGrp="1"/>
+          </p:cNvSpPr>
+          <p:nvPr/>
+        </p:nvSpPr>
+        <p:spPr>
+          <a:xfrm xmlns:a="http://schemas.openxmlformats.org/drawingml/2006/main">
+            <a:off x="1552575" y="1362075"/>
+            <a:ext cx="6343650" cy="6467475"/>
+          </a:xfrm>
+          <a:custGeom xmlns:a="http://schemas.openxmlformats.org/drawingml/2006/main">
+            <a:pathLst>
+              <a:path w="6343650" h="6467475">
+                <a:moveTo>
+                  <a:pt x="11906" y="5695950"/>
+                </a:moveTo>
+                <a:lnTo>
+                  <a:pt x="11906" y="6455569"/>
+                </a:lnTo>
+                <a:lnTo>
+                  <a:pt x="5788819" y="6455569"/>
+                </a:lnTo>
+                <a:lnTo>
+                  <a:pt x="5788819" y="73819"/>
+                </a:lnTo>
+                <a:lnTo>
+                  <a:pt x="6286500" y="73819"/>
+                </a:lnTo>
+                <a:lnTo>
+                  <a:pt x="6286500" y="104775"/>
+                </a:lnTo>
+                <a:lnTo>
+                  <a:pt x="6343650" y="66675"/>
+                </a:lnTo>
+                <a:lnTo>
+                  <a:pt x="6286500" y="28575"/>
+                </a:lnTo>
+                <a:lnTo>
+                  <a:pt x="6286500" y="59531"/>
+                </a:lnTo>
+                <a:lnTo>
+                  <a:pt x="5774531" y="59531"/>
+                </a:lnTo>
+                <a:lnTo>
+                  <a:pt x="5774531" y="6441281"/>
+                </a:lnTo>
+                <a:lnTo>
+                  <a:pt x="26194" y="6441281"/>
+                </a:lnTo>
+                <a:lnTo>
+                  <a:pt x="26194" y="5695950"/>
+                </a:lnTo>
+                <a:close/>
+              </a:path>
+            </a:pathLst>
+          </a:custGeom>
+          <a:solidFill xmlns:a="http://schemas.openxmlformats.org/drawingml/2006/main">
+            <a:srgbClr val="1D2B36"/>
+          </a:solidFill>
+          <a:ln xmlns:a="http://schemas.openxmlformats.org/drawingml/2006/main" w="0">
+            <a:solidFill>
+              <a:srgbClr val="1D2B36"/>
+            </a:solidFill>
+            <a:prstDash val="solid"/>
+          </a:ln>
+        </p:spPr>
+      </p:sp>
+      <p:sp>
+        <p:nvSpPr>
+          <p:cNvPr id="5707" name="rcps-to-candidate-scores-routed-arrow">
+            <a:extLst xmlns:a="http://schemas.openxmlformats.org/drawingml/2006/main">
+              <a:ext uri="{FF2B5EF4-FFF2-40B4-BE49-F238E27FC236}">
+                <a16:creationId xmlns:a16="http://schemas.microsoft.com/office/drawing/2014/main" id="{7A3F411A-EFCA-40D6-991C-56FD9B2B1319}"/>
+              </a:ext>
+            </a:extLst>
+          </p:cNvPr>
+          <p:cNvSpPr>
+            <a:spLocks xmlns:a="http://schemas.openxmlformats.org/drawingml/2006/main" noGrp="1"/>
+          </p:cNvSpPr>
+          <p:nvPr/>
+        </p:nvSpPr>
+        <p:spPr>
+          <a:xfrm xmlns:a="http://schemas.openxmlformats.org/drawingml/2006/main">
+            <a:off x="11620500" y="4610100"/>
+            <a:ext cx="180975" cy="3133725"/>
+          </a:xfrm>
+          <a:custGeom xmlns:a="http://schemas.openxmlformats.org/drawingml/2006/main">
+            <a:pathLst>
+              <a:path w="180975" h="3133725">
+                <a:moveTo>
+                  <a:pt x="0" y="2381"/>
+                </a:moveTo>
+                <a:lnTo>
+                  <a:pt x="178594" y="2381"/>
+                </a:lnTo>
+                <a:lnTo>
+                  <a:pt x="178594" y="3074194"/>
+                </a:lnTo>
+                <a:lnTo>
+                  <a:pt x="57150" y="3074194"/>
+                </a:lnTo>
+                <a:lnTo>
+                  <a:pt x="57150" y="3105150"/>
+                </a:lnTo>
+                <a:lnTo>
+                  <a:pt x="0" y="3067050"/>
+                </a:lnTo>
+                <a:lnTo>
+                  <a:pt x="57150" y="3028950"/>
+                </a:lnTo>
+                <a:lnTo>
+                  <a:pt x="57150" y="3059906"/>
+                </a:lnTo>
+                <a:lnTo>
+                  <a:pt x="164306" y="3059906"/>
+                </a:lnTo>
+                <a:lnTo>
+                  <a:pt x="164306" y="16669"/>
+                </a:lnTo>
+                <a:lnTo>
+                  <a:pt x="0" y="16669"/>
+                </a:lnTo>
+                <a:close/>
+              </a:path>
+            </a:pathLst>
+          </a:custGeom>
+          <a:solidFill xmlns:a="http://schemas.openxmlformats.org/drawingml/2006/main">
+            <a:srgbClr val="0F7040"/>
+          </a:solidFill>
+          <a:ln xmlns:a="http://schemas.openxmlformats.org/drawingml/2006/main" w="0">
+            <a:solidFill>
+              <a:srgbClr val="0F7040"/>
+            </a:solidFill>
+            <a:prstDash val="solid"/>
+          </a:ln>
+        </p:spPr>
+      </p:sp>
     </p:spTree>
     <p:extLst>
       <p:ext uri="{BB962C8B-B14F-4D97-AF65-F5344CB8AC3E}">

</xml_diff>

<commit_message>
docs(paper): finalize camera-ready readability audit
</commit_message>
<xml_diff>
--- a/paper/figures/fig_overview_camera_ready.pptx
+++ b/paper/figures/fig_overview_camera_ready.pptx
@@ -2,13 +2,13 @@
 <file path=ppt/presentation.xml><?xml version="1.0" encoding="utf-8"?>
 <p:presentation xmlns:p="http://schemas.openxmlformats.org/presentationml/2006/main">
   <p:sldMasterIdLst>
-    <p:sldMasterId xmlns:r="http://schemas.openxmlformats.org/officeDocument/2006/relationships" id="2147483648" r:id="R955f202743f9440f"/>
+    <p:sldMasterId xmlns:r="http://schemas.openxmlformats.org/officeDocument/2006/relationships" id="2147483648" r:id="Rb27aad1b00834de9"/>
   </p:sldMasterIdLst>
   <p:notesMasterIdLst>
-    <p:notesMasterId xmlns:r="http://schemas.openxmlformats.org/officeDocument/2006/relationships" r:id="Rdf9340b8106946c2"/>
+    <p:notesMasterId xmlns:r="http://schemas.openxmlformats.org/officeDocument/2006/relationships" r:id="Rf384dd00a2f448f3"/>
   </p:notesMasterIdLst>
   <p:sldIdLst>
-    <p:sldId xmlns:r="http://schemas.openxmlformats.org/officeDocument/2006/relationships" id="256" r:id="R34584c023f254118"/>
+    <p:sldId xmlns:r="http://schemas.openxmlformats.org/officeDocument/2006/relationships" id="256" r:id="Rcf120b5c4e514621"/>
   </p:sldIdLst>
   <p:sldSz cx="16154400" cy="9001125"/>
   <p:notesSz cx="6858000" cy="9144000"/>
@@ -508,7 +508,7 @@
   </p:cSld>
   <p:clrMap bg1="lt1" tx1="dk1" bg2="lt2" tx2="dk2" accent1="accent1" accent2="accent2" accent3="accent3" accent4="accent4" accent5="accent5" accent6="accent6" hlink="hlink" folHlink="folHlink"/>
   <p:sldLayoutIdLst>
-    <p:sldLayoutId xmlns:r="http://schemas.openxmlformats.org/officeDocument/2006/relationships" id="2147483649" r:id="Re860281bae654271"/>
+    <p:sldLayoutId xmlns:r="http://schemas.openxmlformats.org/officeDocument/2006/relationships" id="2147483649" r:id="R242e4ae78a1942fd"/>
   </p:sldLayoutIdLst>
   <p:txStyles>
     <p:titleStyle>
@@ -5413,7 +5413,18 @@
                 <a:ea typeface="Arial"/>
                 <a:cs typeface="Arial"/>
               </a:rPr>
-              <a:t>Cutoffs </a:t>
+              <a:t>Depths</a:t>
+            </a:r>
+            <a:r>
+              <a:rPr sz="1125" b="1" i="0">
+                <a:solidFill>
+                  <a:srgbClr val="34566F"/>
+                </a:solidFill>
+                <a:latin typeface="Arial"/>
+                <a:ea typeface="Arial"/>
+                <a:cs typeface="Arial"/>
+              </a:rPr>
+              <a:t> </a:t>
             </a:r>
             <a:r>
               <a:rPr sz="1125" b="1" i="1">
@@ -9002,7 +9013,7 @@
       </p:sp>
       <p:cxnSp>
         <p:nvCxnSpPr>
-          <p:cNvPr id="5856" name="직선 화살표 연결선 828"/>
+          <p:cNvPr id="6286" name="직선 화살표 연결선 828"/>
           <p:cNvCxnSpPr>
             <a:stCxn xmlns:a="http://schemas.openxmlformats.org/drawingml/2006/main" id="160" idx="3"/>
             <a:endCxn xmlns:a="http://schemas.openxmlformats.org/drawingml/2006/main" id="161" idx="1"/>
@@ -9030,7 +9041,7 @@
       </p:cxnSp>
       <p:cxnSp>
         <p:nvCxnSpPr>
-          <p:cNvPr id="5857" name="직선 화살표 연결선 829"/>
+          <p:cNvPr id="6287" name="직선 화살표 연결선 829"/>
           <p:cNvCxnSpPr>
             <a:stCxn xmlns:a="http://schemas.openxmlformats.org/drawingml/2006/main" id="30" idx="2"/>
             <a:endCxn xmlns:a="http://schemas.openxmlformats.org/drawingml/2006/main" id="33" idx="0"/>
@@ -9058,7 +9069,7 @@
       </p:cxnSp>
       <p:cxnSp>
         <p:nvCxnSpPr>
-          <p:cNvPr id="5858" name="직선 화살표 연결선 830"/>
+          <p:cNvPr id="6288" name="직선 화살표 연결선 830"/>
           <p:cNvCxnSpPr>
             <a:stCxn xmlns:a="http://schemas.openxmlformats.org/drawingml/2006/main" id="33" idx="2"/>
             <a:endCxn xmlns:a="http://schemas.openxmlformats.org/drawingml/2006/main" id="35" idx="0"/>
@@ -9086,7 +9097,7 @@
       </p:cxnSp>
       <p:cxnSp>
         <p:nvCxnSpPr>
-          <p:cNvPr id="5859" name="직선 화살표 연결선 831"/>
+          <p:cNvPr id="6289" name="직선 화살표 연결선 831"/>
           <p:cNvCxnSpPr>
             <a:stCxn xmlns:a="http://schemas.openxmlformats.org/drawingml/2006/main" id="35" idx="2"/>
             <a:endCxn xmlns:a="http://schemas.openxmlformats.org/drawingml/2006/main" id="38" idx="0"/>
@@ -9114,7 +9125,7 @@
       </p:cxnSp>
       <p:cxnSp>
         <p:nvCxnSpPr>
-          <p:cNvPr id="5860" name="직선 화살표 연결선 832"/>
+          <p:cNvPr id="6290" name="직선 화살표 연결선 832"/>
           <p:cNvCxnSpPr>
             <a:stCxn xmlns:a="http://schemas.openxmlformats.org/drawingml/2006/main" id="38" idx="2"/>
             <a:endCxn xmlns:a="http://schemas.openxmlformats.org/drawingml/2006/main" id="40" idx="0"/>
@@ -9142,7 +9153,7 @@
       </p:cxnSp>
       <p:cxnSp>
         <p:nvCxnSpPr>
-          <p:cNvPr id="5861" name="직선 화살표 연결선 833"/>
+          <p:cNvPr id="6291" name="직선 화살표 연결선 833"/>
           <p:cNvCxnSpPr>
             <a:stCxn xmlns:a="http://schemas.openxmlformats.org/drawingml/2006/main" id="40" idx="2"/>
             <a:endCxn xmlns:a="http://schemas.openxmlformats.org/drawingml/2006/main" id="43" idx="0"/>
@@ -9402,7 +9413,7 @@
       </p:sp>
       <p:cxnSp>
         <p:nvCxnSpPr>
-          <p:cNvPr id="5870" name="직선 화살표 연결선 852"/>
+          <p:cNvPr id="6300" name="직선 화살표 연결선 852"/>
           <p:cNvCxnSpPr>
             <a:stCxn xmlns:a="http://schemas.openxmlformats.org/drawingml/2006/main" id="62" idx="2"/>
             <a:endCxn xmlns:a="http://schemas.openxmlformats.org/drawingml/2006/main" id="72" idx="0"/>
@@ -9430,7 +9441,7 @@
       </p:cxnSp>
       <p:cxnSp>
         <p:nvCxnSpPr>
-          <p:cNvPr id="5871" name="직선 화살표 연결선 853"/>
+          <p:cNvPr id="6301" name="직선 화살표 연결선 853"/>
           <p:cNvCxnSpPr>
             <a:stCxn xmlns:a="http://schemas.openxmlformats.org/drawingml/2006/main" id="72" idx="2"/>
             <a:endCxn xmlns:a="http://schemas.openxmlformats.org/drawingml/2006/main" id="75" idx="0"/>
@@ -9458,7 +9469,7 @@
       </p:cxnSp>
       <p:cxnSp>
         <p:nvCxnSpPr>
-          <p:cNvPr id="5872" name="직선 화살표 연결선 854"/>
+          <p:cNvPr id="6302" name="직선 화살표 연결선 854"/>
           <p:cNvCxnSpPr>
             <a:stCxn xmlns:a="http://schemas.openxmlformats.org/drawingml/2006/main" id="75" idx="2"/>
             <a:endCxn xmlns:a="http://schemas.openxmlformats.org/drawingml/2006/main" id="77" idx="0"/>
@@ -9486,7 +9497,7 @@
       </p:cxnSp>
       <p:cxnSp>
         <p:nvCxnSpPr>
-          <p:cNvPr id="5873" name="직선 화살표 연결선 855"/>
+          <p:cNvPr id="6303" name="직선 화살표 연결선 855"/>
           <p:cNvCxnSpPr>
             <a:stCxn xmlns:a="http://schemas.openxmlformats.org/drawingml/2006/main" id="77" idx="2"/>
             <a:endCxn xmlns:a="http://schemas.openxmlformats.org/drawingml/2006/main" id="82" idx="0"/>
@@ -9746,7 +9757,7 @@
       </p:sp>
       <p:cxnSp>
         <p:nvCxnSpPr>
-          <p:cNvPr id="5882" name="직선 화살표 연결선 867"/>
+          <p:cNvPr id="6312" name="직선 화살표 연결선 867"/>
           <p:cNvCxnSpPr>
             <a:stCxn xmlns:a="http://schemas.openxmlformats.org/drawingml/2006/main" id="197" idx="3"/>
             <a:endCxn xmlns:a="http://schemas.openxmlformats.org/drawingml/2006/main" id="198" idx="1"/>
@@ -9774,7 +9785,7 @@
       </p:cxnSp>
       <p:cxnSp>
         <p:nvCxnSpPr>
-          <p:cNvPr id="5883" name="직선 화살표 연결선 868"/>
+          <p:cNvPr id="6313" name="직선 화살표 연결선 868"/>
           <p:cNvCxnSpPr>
             <a:stCxn xmlns:a="http://schemas.openxmlformats.org/drawingml/2006/main" id="198" idx="0"/>
           </p:cNvCxnSpPr>
@@ -9801,7 +9812,7 @@
       </p:cxnSp>
       <p:cxnSp>
         <p:nvCxnSpPr>
-          <p:cNvPr id="5884" name="직선 화살표 연결선 869"/>
+          <p:cNvPr id="6314" name="직선 화살표 연결선 869"/>
           <p:cNvCxnSpPr>
             <a:endCxn xmlns:a="http://schemas.openxmlformats.org/drawingml/2006/main" id="95" idx="1"/>
           </p:cNvCxnSpPr>
@@ -9828,7 +9839,7 @@
       </p:cxnSp>
       <p:cxnSp>
         <p:nvCxnSpPr>
-          <p:cNvPr id="5885" name="직선 화살표 연결선 870"/>
+          <p:cNvPr id="6315" name="직선 화살표 연결선 870"/>
           <p:cNvCxnSpPr>
             <a:stCxn xmlns:a="http://schemas.openxmlformats.org/drawingml/2006/main" id="95" idx="2"/>
             <a:endCxn xmlns:a="http://schemas.openxmlformats.org/drawingml/2006/main" id="123" idx="0"/>
@@ -9856,7 +9867,7 @@
       </p:cxnSp>
       <p:cxnSp>
         <p:nvCxnSpPr>
-          <p:cNvPr id="5886" name="연결선: 꺾임 872"/>
+          <p:cNvPr id="6316" name="연결선: 꺾임 872"/>
           <p:cNvCxnSpPr>
             <a:stCxn xmlns:a="http://schemas.openxmlformats.org/drawingml/2006/main" id="211" idx="2"/>
             <a:endCxn xmlns:a="http://schemas.openxmlformats.org/drawingml/2006/main" id="128" idx="0"/>
@@ -9886,7 +9897,7 @@
       </p:cxnSp>
       <p:cxnSp>
         <p:nvCxnSpPr>
-          <p:cNvPr id="5887" name="직선 화살표 연결선 871"/>
+          <p:cNvPr id="6317" name="직선 화살표 연결선 871"/>
           <p:cNvCxnSpPr>
             <a:stCxn xmlns:a="http://schemas.openxmlformats.org/drawingml/2006/main" id="123" idx="2"/>
             <a:endCxn xmlns:a="http://schemas.openxmlformats.org/drawingml/2006/main" id="125" idx="0"/>
@@ -9914,7 +9925,7 @@
       </p:cxnSp>
       <p:cxnSp>
         <p:nvCxnSpPr>
-          <p:cNvPr id="5888" name="연결선: 꺾임 874"/>
+          <p:cNvPr id="6318" name="연결선: 꺾임 874"/>
           <p:cNvCxnSpPr>
             <a:stCxn xmlns:a="http://schemas.openxmlformats.org/drawingml/2006/main" id="128" idx="2"/>
             <a:endCxn xmlns:a="http://schemas.openxmlformats.org/drawingml/2006/main" id="134" idx="0"/>
@@ -9945,7 +9956,7 @@
       </p:cxnSp>
       <p:cxnSp>
         <p:nvCxnSpPr>
-          <p:cNvPr id="5889" name="직선 화살표 연결선 875"/>
+          <p:cNvPr id="6319" name="직선 화살표 연결선 875"/>
           <p:cNvCxnSpPr>
             <a:stCxn xmlns:a="http://schemas.openxmlformats.org/drawingml/2006/main" id="130" idx="2"/>
             <a:endCxn xmlns:a="http://schemas.openxmlformats.org/drawingml/2006/main" id="134" idx="0"/>
@@ -9973,7 +9984,7 @@
       </p:cxnSp>
       <p:cxnSp>
         <p:nvCxnSpPr>
-          <p:cNvPr id="5890" name="연결선: 꺾임 876"/>
+          <p:cNvPr id="6320" name="연결선: 꺾임 876"/>
           <p:cNvCxnSpPr>
             <a:stCxn xmlns:a="http://schemas.openxmlformats.org/drawingml/2006/main" id="132" idx="2"/>
             <a:endCxn xmlns:a="http://schemas.openxmlformats.org/drawingml/2006/main" id="134" idx="0"/>
@@ -10004,7 +10015,7 @@
       </p:cxnSp>
       <p:cxnSp>
         <p:nvCxnSpPr>
-          <p:cNvPr id="5891" name="연결선: 꺾임 877"/>
+          <p:cNvPr id="6321" name="연결선: 꺾임 877"/>
           <p:cNvCxnSpPr>
             <a:stCxn xmlns:a="http://schemas.openxmlformats.org/drawingml/2006/main" id="134" idx="2"/>
             <a:endCxn xmlns:a="http://schemas.openxmlformats.org/drawingml/2006/main" id="139" idx="0"/>
@@ -10035,7 +10046,7 @@
       </p:cxnSp>
       <p:cxnSp>
         <p:nvCxnSpPr>
-          <p:cNvPr id="5892" name="직선 화살표 연결선 878"/>
+          <p:cNvPr id="6322" name="직선 화살표 연결선 878"/>
           <p:cNvCxnSpPr>
             <a:stCxn xmlns:a="http://schemas.openxmlformats.org/drawingml/2006/main" id="134" idx="2"/>
             <a:endCxn xmlns:a="http://schemas.openxmlformats.org/drawingml/2006/main" id="142" idx="0"/>
@@ -10063,7 +10074,7 @@
       </p:cxnSp>
       <p:cxnSp>
         <p:nvCxnSpPr>
-          <p:cNvPr id="5893" name="연결선: 꺾임 879"/>
+          <p:cNvPr id="6323" name="연결선: 꺾임 879"/>
           <p:cNvCxnSpPr>
             <a:stCxn xmlns:a="http://schemas.openxmlformats.org/drawingml/2006/main" id="134" idx="2"/>
             <a:endCxn xmlns:a="http://schemas.openxmlformats.org/drawingml/2006/main" id="145" idx="0"/>
@@ -10094,7 +10105,7 @@
       </p:cxnSp>
       <p:cxnSp>
         <p:nvCxnSpPr>
-          <p:cNvPr id="5894" name="직선 화살표 연결선 880"/>
+          <p:cNvPr id="6324" name="직선 화살표 연결선 880"/>
           <p:cNvCxnSpPr>
             <a:stCxn xmlns:a="http://schemas.openxmlformats.org/drawingml/2006/main" id="139" idx="2"/>
             <a:endCxn xmlns:a="http://schemas.openxmlformats.org/drawingml/2006/main" id="148" idx="0"/>
@@ -10122,7 +10133,7 @@
       </p:cxnSp>
       <p:cxnSp>
         <p:nvCxnSpPr>
-          <p:cNvPr id="5895" name="직선 화살표 연결선 881"/>
+          <p:cNvPr id="6325" name="직선 화살표 연결선 881"/>
           <p:cNvCxnSpPr>
             <a:stCxn xmlns:a="http://schemas.openxmlformats.org/drawingml/2006/main" id="142" idx="2"/>
             <a:endCxn xmlns:a="http://schemas.openxmlformats.org/drawingml/2006/main" id="150" idx="0"/>
@@ -10150,7 +10161,7 @@
       </p:cxnSp>
       <p:cxnSp>
         <p:nvCxnSpPr>
-          <p:cNvPr id="5896" name="직선 화살표 연결선 882"/>
+          <p:cNvPr id="6326" name="직선 화살표 연결선 882"/>
           <p:cNvCxnSpPr>
             <a:stCxn xmlns:a="http://schemas.openxmlformats.org/drawingml/2006/main" id="145" idx="2"/>
             <a:endCxn xmlns:a="http://schemas.openxmlformats.org/drawingml/2006/main" id="152" idx="0"/>
@@ -10178,7 +10189,7 @@
       </p:cxnSp>
       <p:cxnSp>
         <p:nvCxnSpPr>
-          <p:cNvPr id="5897" name="연결선: 꺾임 883"/>
+          <p:cNvPr id="6327" name="연결선: 꺾임 883"/>
           <p:cNvCxnSpPr>
             <a:stCxn xmlns:a="http://schemas.openxmlformats.org/drawingml/2006/main" id="148" idx="2"/>
             <a:endCxn xmlns:a="http://schemas.openxmlformats.org/drawingml/2006/main" id="154" idx="0"/>
@@ -10295,7 +10306,7 @@
       </p:sp>
       <p:cxnSp>
         <p:nvCxnSpPr>
-          <p:cNvPr id="5901" name="직선 화살표 연결선 184"/>
+          <p:cNvPr id="6331" name="직선 화살표 연결선 184"/>
           <p:cNvCxnSpPr>
             <a:stCxn xmlns:a="http://schemas.openxmlformats.org/drawingml/2006/main" id="51" idx="2"/>
             <a:endCxn xmlns:a="http://schemas.openxmlformats.org/drawingml/2006/main" id="53" idx="0"/>
@@ -10323,7 +10334,7 @@
       </p:cxnSp>
       <p:cxnSp>
         <p:nvCxnSpPr>
-          <p:cNvPr id="5902" name="직선 화살표 연결선 188"/>
+          <p:cNvPr id="6332" name="직선 화살표 연결선 188"/>
           <p:cNvCxnSpPr>
             <a:stCxn xmlns:a="http://schemas.openxmlformats.org/drawingml/2006/main" id="53" idx="2"/>
             <a:endCxn xmlns:a="http://schemas.openxmlformats.org/drawingml/2006/main" id="55" idx="0"/>
@@ -10351,7 +10362,7 @@
       </p:cxnSp>
       <p:cxnSp>
         <p:nvCxnSpPr>
-          <p:cNvPr id="5903" name="직선 화살표 연결선 200"/>
+          <p:cNvPr id="6333" name="직선 화살표 연결선 200"/>
           <p:cNvCxnSpPr>
             <a:stCxn xmlns:a="http://schemas.openxmlformats.org/drawingml/2006/main" id="55" idx="2"/>
             <a:endCxn xmlns:a="http://schemas.openxmlformats.org/drawingml/2006/main" id="57" idx="0"/>
@@ -10379,7 +10390,7 @@
       </p:cxnSp>
       <p:cxnSp>
         <p:nvCxnSpPr>
-          <p:cNvPr id="5904" name="연결선: 꺾임 227"/>
+          <p:cNvPr id="6334" name="연결선: 꺾임 227"/>
           <p:cNvCxnSpPr/>
           <p:nvPr/>
         </p:nvCxnSpPr>
@@ -10404,7 +10415,7 @@
       </p:cxnSp>
       <p:cxnSp>
         <p:nvCxnSpPr>
-          <p:cNvPr id="5905" name="직선 화살표 연결선 241"/>
+          <p:cNvPr id="6335" name="직선 화살표 연결선 241"/>
           <p:cNvCxnSpPr>
             <a:stCxn xmlns:a="http://schemas.openxmlformats.org/drawingml/2006/main" id="152" idx="2"/>
             <a:endCxn xmlns:a="http://schemas.openxmlformats.org/drawingml/2006/main" id="248" idx="0"/>
@@ -10432,7 +10443,7 @@
       </p:cxnSp>
       <p:cxnSp>
         <p:nvCxnSpPr>
-          <p:cNvPr id="5906" name="직선 화살표 연결선 253"/>
+          <p:cNvPr id="6336" name="직선 화살표 연결선 253"/>
           <p:cNvCxnSpPr>
             <a:stCxn xmlns:a="http://schemas.openxmlformats.org/drawingml/2006/main" id="150" idx="2"/>
             <a:endCxn xmlns:a="http://schemas.openxmlformats.org/drawingml/2006/main" id="769" idx="0"/>
@@ -10460,14 +10471,14 @@
       </p:cxnSp>
       <p:pic>
         <p:nvPicPr>
-          <p:cNvPr id="5907" name="그림 162"/>
+          <p:cNvPr id="6337" name="그림 162"/>
           <p:cNvPicPr>
             <a:picLocks xmlns:a="http://schemas.openxmlformats.org/drawingml/2006/main" noChangeAspect="1"/>
           </p:cNvPicPr>
           <p:nvPr/>
         </p:nvPicPr>
         <p:blipFill>
-          <a:blip xmlns:r="http://schemas.openxmlformats.org/officeDocument/2006/relationships" xmlns:a="http://schemas.openxmlformats.org/drawingml/2006/main" r:embed="Rff6bfb68e8d44fc1">
+          <a:blip xmlns:r="http://schemas.openxmlformats.org/officeDocument/2006/relationships" xmlns:a="http://schemas.openxmlformats.org/drawingml/2006/main" r:embed="Rb09442ce67324ac6">
             <a:biLevel thresh="75000"/>
           </a:blip>
           <a:stretch xmlns:a="http://schemas.openxmlformats.org/drawingml/2006/main">
@@ -10486,14 +10497,14 @@
       </p:pic>
       <p:pic>
         <p:nvPicPr>
-          <p:cNvPr id="5908" name="그림 169"/>
+          <p:cNvPr id="6338" name="그림 169"/>
           <p:cNvPicPr>
             <a:picLocks xmlns:a="http://schemas.openxmlformats.org/drawingml/2006/main" noChangeAspect="1"/>
           </p:cNvPicPr>
           <p:nvPr/>
         </p:nvPicPr>
         <p:blipFill>
-          <a:blip xmlns:r="http://schemas.openxmlformats.org/officeDocument/2006/relationships" xmlns:a="http://schemas.openxmlformats.org/drawingml/2006/main" r:embed="Rf2c901423a1c4f95">
+          <a:blip xmlns:r="http://schemas.openxmlformats.org/officeDocument/2006/relationships" xmlns:a="http://schemas.openxmlformats.org/drawingml/2006/main" r:embed="R5b18427182694db9">
             <a:duotone>
               <a:schemeClr val="accent4">
                 <a:shade val="45000"/>
@@ -10518,7 +10529,7 @@
       </p:pic>
       <p:cxnSp>
         <p:nvCxnSpPr>
-          <p:cNvPr id="5909" name="직선 화살표 연결선 187"/>
+          <p:cNvPr id="6339" name="직선 화살표 연결선 187"/>
           <p:cNvCxnSpPr>
             <a:stCxn xmlns:a="http://schemas.openxmlformats.org/drawingml/2006/main" id="33" idx="3"/>
             <a:endCxn xmlns:a="http://schemas.openxmlformats.org/drawingml/2006/main" id="51" idx="1"/>
@@ -11073,7 +11084,7 @@
       </p:sp>
       <p:cxnSp>
         <p:nvCxnSpPr>
-          <p:cNvPr id="5920" name="직선 화살표 연결선 769"/>
+          <p:cNvPr id="6350" name="직선 화살표 연결선 769"/>
           <p:cNvCxnSpPr>
             <a:stCxn xmlns:a="http://schemas.openxmlformats.org/drawingml/2006/main" id="154" idx="3"/>
             <a:endCxn xmlns:a="http://schemas.openxmlformats.org/drawingml/2006/main" id="236" idx="1"/>

</xml_diff>